<commit_message>
Separa NRs geral e NR-10 aprofundada em apresentações e páginas distintas
- criar_pptx.py: NRs geral (12 slides, NR-01/05/06/15/16/17/23/35) + NR-10 aprofundada (15 slides, LOTO/AR/PT/zonas/EPIs/ferramentas)
- index.html: cards e páginas separados para NRs geral e NR-10; remove slideshow JS/CSS estático
- Atualiza MP4s: 02_Normas_Regulamentadoras, 04_NR10 e 05_Extintores regravados

Co-Authored-By: Claude Sonnet 4.6 <noreply@anthropic.com>
</commit_message>
<xml_diff>
--- a/04_NR10.pptx
+++ b/04_NR10.pptx
@@ -15,6 +15,11 @@
     <p:sldId id="263" r:id="rId15"/>
     <p:sldId id="264" r:id="rId16"/>
     <p:sldId id="265" r:id="rId17"/>
+    <p:sldId id="266" r:id="rId18"/>
+    <p:sldId id="267" r:id="rId19"/>
+    <p:sldId id="268" r:id="rId20"/>
+    <p:sldId id="269" r:id="rId21"/>
+    <p:sldId id="270" r:id="rId22"/>
   </p:sldIdLst>
   <p:sldSz cx="12188952" cy="6858000" type="screen4x3"/>
   <p:notesSz cx="6858000" cy="9144000"/>
@@ -511,7 +516,7 @@
           <a:lstStyle/>
           <a:p>
             <a:r>
-              <a:t>Bem-vindos à apresentação sobre a NR-10, norma que regulamenta a segurança em instalações e serviços em eletricidade no Brasil. Vamos estudar os principais conceitos, perfis profissionais, sequência de controle e os equipamentos de proteção exigidos.</a:t>
+              <a:t>Bem-vindos à aula aprofundada sobre a NR-10, a norma que regulamenta a segurança em instalações e serviços em eletricidade. Diferente da visão geral das NRs, aqui vamos detalhar cada aspecto técnico desta norma fundamental para quem trabalha com sistemas elétricos.</a:t>
             </a:r>
           </a:p>
         </p:txBody>
@@ -581,7 +586,357 @@
           <a:lstStyle/>
           <a:p>
             <a:r>
-              <a:t>Vamos revisar os pontos essenciais da NR-10. A norma se aplica a todos os trabalhadores expostos a riscos elétricos. Existem três perfis profissionais: capacitado, qualificado e habilitado. Antes de qualquer intervenção, os cinco passos da sequência de controle são obrigatórios. Nunca presuma que está desenergizado — teste sempre. Trabalho em instalação energizada é exceção e exige documentação e EPIs específicos. A reciclagem do treinamento é obrigatória a cada dois anos.</a:t>
+              <a:t>Conhecer os riscos elétricos é fundamental para preveni-los. O choque elétrico ocorre quando a corrente elétrica passa pelo corpo. Correntes acima de cinquenta miliamperes podem causar fibrilação ventricular e morte. O arco elétrico é ainda mais perigoso: ele atinge temperaturas acima de vinte mil graus Celsius, projeta metal fundido e emite radiação ultravioleta intensa. A tensão de passo ocorre quando um condutor cai no chão e cria diferença de potencial entre os dois pés. Neste caso, aproxime-se em passos curtos ou pule com os dois pés juntos.</a:t>
+            </a:r>
+          </a:p>
+        </p:txBody>
+      </p:sp>
+      <p:sp>
+        <p:nvSpPr>
+          <p:cNvPr id="4" name="Slide Number Placeholder 3"/>
+          <p:cNvSpPr>
+            <a:spLocks noGrp="1"/>
+          </p:cNvSpPr>
+          <p:nvPr>
+            <p:ph type="sldNum" idx="5" sz="quarter"/>
+          </p:nvPr>
+        </p:nvSpPr>
+        <p:spPr/>
+      </p:sp>
+    </p:spTree>
+  </p:cSld>
+  <p:clrMapOvr>
+    <a:masterClrMapping/>
+  </p:clrMapOvr>
+</p:notes>
+</file>
+
+<file path=ppt/notesSlides/notesSlide11.xml><?xml version="1.0" encoding="utf-8"?>
+<p:notes xmlns:a="http://schemas.openxmlformats.org/drawingml/2006/main" xmlns:p="http://schemas.openxmlformats.org/presentationml/2006/main" xmlns:r="http://schemas.openxmlformats.org/officeDocument/2006/relationships">
+  <p:cSld>
+    <p:spTree>
+      <p:nvGrpSpPr>
+        <p:cNvPr id="1" name=""/>
+        <p:cNvGrpSpPr/>
+        <p:nvPr/>
+      </p:nvGrpSpPr>
+      <p:grpSpPr>
+        <a:xfrm>
+          <a:off x="0" y="0"/>
+          <a:ext cx="0" cy="0"/>
+          <a:chOff x="0" y="0"/>
+          <a:chExt cx="0" cy="0"/>
+        </a:xfrm>
+      </p:grpSpPr>
+      <p:sp>
+        <p:nvSpPr>
+          <p:cNvPr id="2" name="Slide Image Placeholder 1"/>
+          <p:cNvSpPr>
+            <a:spLocks noGrp="1"/>
+          </p:cNvSpPr>
+          <p:nvPr>
+            <p:ph type="sldImg" idx="2"/>
+          </p:nvPr>
+        </p:nvSpPr>
+        <p:spPr/>
+      </p:sp>
+      <p:sp>
+        <p:nvSpPr>
+          <p:cNvPr id="3" name="Notes Placeholder 2"/>
+          <p:cNvSpPr>
+            <a:spLocks noGrp="1"/>
+          </p:cNvSpPr>
+          <p:nvPr>
+            <p:ph type="body" idx="3" sz="quarter"/>
+          </p:nvPr>
+        </p:nvSpPr>
+        <p:spPr/>
+        <p:txBody>
+          <a:bodyPr/>
+          <a:lstStyle/>
+          <a:p>
+            <a:r>
+              <a:t>Os EPIs para trabalho elétrico são determinados conjuntamente pela NR-06 e NR-10. As luvas dielétricas são o EPI mais importante: devem ser inspecionadas antes de cada uso enrolando-as do punho à ponta para detectar qualquer furo invisível. O capacete deve ser da classe B, que isola até vinte mil volts, e deve ter jugular. O uniforme anti-chama é feito de tecido tratado que não derrete nem pega fogo facilmente. Qualquer tecido sintético como poliéster é proibido, pois derrete e gruda na pele em contato com o arco elétrico.</a:t>
+            </a:r>
+          </a:p>
+        </p:txBody>
+      </p:sp>
+      <p:sp>
+        <p:nvSpPr>
+          <p:cNvPr id="4" name="Slide Number Placeholder 3"/>
+          <p:cNvSpPr>
+            <a:spLocks noGrp="1"/>
+          </p:cNvSpPr>
+          <p:nvPr>
+            <p:ph type="sldNum" idx="5" sz="quarter"/>
+          </p:nvPr>
+        </p:nvSpPr>
+        <p:spPr/>
+      </p:sp>
+    </p:spTree>
+  </p:cSld>
+  <p:clrMapOvr>
+    <a:masterClrMapping/>
+  </p:clrMapOvr>
+</p:notes>
+</file>
+
+<file path=ppt/notesSlides/notesSlide12.xml><?xml version="1.0" encoding="utf-8"?>
+<p:notes xmlns:a="http://schemas.openxmlformats.org/drawingml/2006/main" xmlns:p="http://schemas.openxmlformats.org/presentationml/2006/main" xmlns:r="http://schemas.openxmlformats.org/officeDocument/2006/relationships">
+  <p:cSld>
+    <p:spTree>
+      <p:nvGrpSpPr>
+        <p:cNvPr id="1" name=""/>
+        <p:cNvGrpSpPr/>
+        <p:nvPr/>
+      </p:nvGrpSpPr>
+      <p:grpSpPr>
+        <a:xfrm>
+          <a:off x="0" y="0"/>
+          <a:ext cx="0" cy="0"/>
+          <a:chOff x="0" y="0"/>
+          <a:chExt cx="0" cy="0"/>
+        </a:xfrm>
+      </p:grpSpPr>
+      <p:sp>
+        <p:nvSpPr>
+          <p:cNvPr id="2" name="Slide Image Placeholder 1"/>
+          <p:cNvSpPr>
+            <a:spLocks noGrp="1"/>
+          </p:cNvSpPr>
+          <p:nvPr>
+            <p:ph type="sldImg" idx="2"/>
+          </p:nvPr>
+        </p:nvSpPr>
+        <p:spPr/>
+      </p:sp>
+      <p:sp>
+        <p:nvSpPr>
+          <p:cNvPr id="3" name="Notes Placeholder 2"/>
+          <p:cNvSpPr>
+            <a:spLocks noGrp="1"/>
+          </p:cNvSpPr>
+          <p:nvPr>
+            <p:ph type="body" idx="3" sz="quarter"/>
+          </p:nvPr>
+        </p:nvSpPr>
+        <p:spPr/>
+        <p:txBody>
+          <a:bodyPr/>
+          <a:lstStyle/>
+          <a:p>
+            <a:r>
+              <a:t>As ferramentas dielétricas são especialmente projetadas para uso em instalações elétricas. Elas possuem cabo e corpo com isolamento que suportam até mil volts em corrente alternada ou mil e quinhentos volts em corrente contínua, conforme a NBR IEC 60900. Antes de cada uso, o trabalhador deve inspecionar visualmente a ferramenta, verificando se há trincas, desgastes ou danos no isolamento. Qualquer ferramenta com isolamento comprometido deve ser retirada de uso imediatamente. Usar uma ferramenta convencional em instalação energizada é uma violação grave da NR-10.</a:t>
+            </a:r>
+          </a:p>
+        </p:txBody>
+      </p:sp>
+      <p:sp>
+        <p:nvSpPr>
+          <p:cNvPr id="4" name="Slide Number Placeholder 3"/>
+          <p:cNvSpPr>
+            <a:spLocks noGrp="1"/>
+          </p:cNvSpPr>
+          <p:nvPr>
+            <p:ph type="sldNum" idx="5" sz="quarter"/>
+          </p:nvPr>
+        </p:nvSpPr>
+        <p:spPr/>
+      </p:sp>
+    </p:spTree>
+  </p:cSld>
+  <p:clrMapOvr>
+    <a:masterClrMapping/>
+  </p:clrMapOvr>
+</p:notes>
+</file>
+
+<file path=ppt/notesSlides/notesSlide13.xml><?xml version="1.0" encoding="utf-8"?>
+<p:notes xmlns:a="http://schemas.openxmlformats.org/drawingml/2006/main" xmlns:p="http://schemas.openxmlformats.org/presentationml/2006/main" xmlns:r="http://schemas.openxmlformats.org/officeDocument/2006/relationships">
+  <p:cSld>
+    <p:spTree>
+      <p:nvGrpSpPr>
+        <p:cNvPr id="1" name=""/>
+        <p:cNvGrpSpPr/>
+        <p:nvPr/>
+      </p:nvGrpSpPr>
+      <p:grpSpPr>
+        <a:xfrm>
+          <a:off x="0" y="0"/>
+          <a:ext cx="0" cy="0"/>
+          <a:chOff x="0" y="0"/>
+          <a:chExt cx="0" cy="0"/>
+        </a:xfrm>
+      </p:grpSpPr>
+      <p:sp>
+        <p:nvSpPr>
+          <p:cNvPr id="2" name="Slide Image Placeholder 1"/>
+          <p:cNvSpPr>
+            <a:spLocks noGrp="1"/>
+          </p:cNvSpPr>
+          <p:nvPr>
+            <p:ph type="sldImg" idx="2"/>
+          </p:nvPr>
+        </p:nvSpPr>
+        <p:spPr/>
+      </p:sp>
+      <p:sp>
+        <p:nvSpPr>
+          <p:cNvPr id="3" name="Notes Placeholder 2"/>
+          <p:cNvSpPr>
+            <a:spLocks noGrp="1"/>
+          </p:cNvSpPr>
+          <p:nvPr>
+            <p:ph type="body" idx="3" sz="quarter"/>
+          </p:nvPr>
+        </p:nvSpPr>
+        <p:spPr/>
+        <p:txBody>
+          <a:bodyPr/>
+          <a:lstStyle/>
+          <a:p>
+            <a:r>
+              <a:t>O empregador tem responsabilidades amplas e específicas definidas pela NR-10. Ele deve garantir que as instalações sejam seguras e conformes com a norma, manter o Prontuário de Instalações sempre atualizado e fornecer gratuitamente todos os EPIs dielétricos necessários. A reciclagem do treinamento NR-10 é obrigatória a cada dois anos ou sempre que houver mudança nas condições ou nos riscos da instalação. O sistema LOTO deve ser implementado e mantido como procedimento padrão da empresa.</a:t>
+            </a:r>
+          </a:p>
+        </p:txBody>
+      </p:sp>
+      <p:sp>
+        <p:nvSpPr>
+          <p:cNvPr id="4" name="Slide Number Placeholder 3"/>
+          <p:cNvSpPr>
+            <a:spLocks noGrp="1"/>
+          </p:cNvSpPr>
+          <p:nvPr>
+            <p:ph type="sldNum" idx="5" sz="quarter"/>
+          </p:nvPr>
+        </p:nvSpPr>
+        <p:spPr/>
+      </p:sp>
+    </p:spTree>
+  </p:cSld>
+  <p:clrMapOvr>
+    <a:masterClrMapping/>
+  </p:clrMapOvr>
+</p:notes>
+</file>
+
+<file path=ppt/notesSlides/notesSlide14.xml><?xml version="1.0" encoding="utf-8"?>
+<p:notes xmlns:a="http://schemas.openxmlformats.org/drawingml/2006/main" xmlns:p="http://schemas.openxmlformats.org/presentationml/2006/main" xmlns:r="http://schemas.openxmlformats.org/officeDocument/2006/relationships">
+  <p:cSld>
+    <p:spTree>
+      <p:nvGrpSpPr>
+        <p:cNvPr id="1" name=""/>
+        <p:cNvGrpSpPr/>
+        <p:nvPr/>
+      </p:nvGrpSpPr>
+      <p:grpSpPr>
+        <a:xfrm>
+          <a:off x="0" y="0"/>
+          <a:ext cx="0" cy="0"/>
+          <a:chOff x="0" y="0"/>
+          <a:chExt cx="0" cy="0"/>
+        </a:xfrm>
+      </p:grpSpPr>
+      <p:sp>
+        <p:nvSpPr>
+          <p:cNvPr id="2" name="Slide Image Placeholder 1"/>
+          <p:cNvSpPr>
+            <a:spLocks noGrp="1"/>
+          </p:cNvSpPr>
+          <p:nvPr>
+            <p:ph type="sldImg" idx="2"/>
+          </p:nvPr>
+        </p:nvSpPr>
+        <p:spPr/>
+      </p:sp>
+      <p:sp>
+        <p:nvSpPr>
+          <p:cNvPr id="3" name="Notes Placeholder 2"/>
+          <p:cNvSpPr>
+            <a:spLocks noGrp="1"/>
+          </p:cNvSpPr>
+          <p:nvPr>
+            <p:ph type="body" idx="3" sz="quarter"/>
+          </p:nvPr>
+        </p:nvSpPr>
+        <p:spPr/>
+        <p:txBody>
+          <a:bodyPr/>
+          <a:lstStyle/>
+          <a:p>
+            <a:r>
+              <a:t>O trabalhador também tem responsabilidades claras na NR-10. A principal delas é seguir sempre a sequência de controle antes de qualquer intervenção. Nunca presuma que uma instalação está desenergizada — sempre teste com instrumento. O Direito de Recusa é um direito fundamental: o trabalhador pode e deve recusar qualquer tarefa que represente risco grave e iminente à sua integridade. Esta recusa deve ser comunicada formalmente ao superior e registrada por escrito. O trabalhador não pode sofrer nenhuma penalidade por exercer este direito.</a:t>
+            </a:r>
+          </a:p>
+        </p:txBody>
+      </p:sp>
+      <p:sp>
+        <p:nvSpPr>
+          <p:cNvPr id="4" name="Slide Number Placeholder 3"/>
+          <p:cNvSpPr>
+            <a:spLocks noGrp="1"/>
+          </p:cNvSpPr>
+          <p:nvPr>
+            <p:ph type="sldNum" idx="5" sz="quarter"/>
+          </p:nvPr>
+        </p:nvSpPr>
+        <p:spPr/>
+      </p:sp>
+    </p:spTree>
+  </p:cSld>
+  <p:clrMapOvr>
+    <a:masterClrMapping/>
+  </p:clrMapOvr>
+</p:notes>
+</file>
+
+<file path=ppt/notesSlides/notesSlide15.xml><?xml version="1.0" encoding="utf-8"?>
+<p:notes xmlns:a="http://schemas.openxmlformats.org/drawingml/2006/main" xmlns:p="http://schemas.openxmlformats.org/presentationml/2006/main" xmlns:r="http://schemas.openxmlformats.org/officeDocument/2006/relationships">
+  <p:cSld>
+    <p:spTree>
+      <p:nvGrpSpPr>
+        <p:cNvPr id="1" name=""/>
+        <p:cNvGrpSpPr/>
+        <p:nvPr/>
+      </p:nvGrpSpPr>
+      <p:grpSpPr>
+        <a:xfrm>
+          <a:off x="0" y="0"/>
+          <a:ext cx="0" cy="0"/>
+          <a:chOff x="0" y="0"/>
+          <a:chExt cx="0" cy="0"/>
+        </a:xfrm>
+      </p:grpSpPr>
+      <p:sp>
+        <p:nvSpPr>
+          <p:cNvPr id="2" name="Slide Image Placeholder 1"/>
+          <p:cNvSpPr>
+            <a:spLocks noGrp="1"/>
+          </p:cNvSpPr>
+          <p:nvPr>
+            <p:ph type="sldImg" idx="2"/>
+          </p:nvPr>
+        </p:nvSpPr>
+        <p:spPr/>
+      </p:sp>
+      <p:sp>
+        <p:nvSpPr>
+          <p:cNvPr id="3" name="Notes Placeholder 2"/>
+          <p:cNvSpPr>
+            <a:spLocks noGrp="1"/>
+          </p:cNvSpPr>
+          <p:nvPr>
+            <p:ph type="body" idx="3" sz="quarter"/>
+          </p:nvPr>
+        </p:nvSpPr>
+        <p:spPr/>
+        <p:txBody>
+          <a:bodyPr/>
+          <a:lstStyle/>
+          <a:p>
+            <a:r>
+              <a:t>Vamos revisar os dez pontos essenciais da NR-10. Primeiro: a norma se aplica a todos expostos ao risco elétrico, não só eletricistas. Segundo: existem três perfis profissionais — capacitado, qualificado e habilitado. Terceiro: o Prontuário é obrigatório e responsabilidade do empregador. Quarto: os cinco passos LOTO devem ser seguidos antes de qualquer intervenção. Quinto: nunca presuma tensão zero — sempre verifique com instrumento calibrado. Sexto: trabalho energizado é exceção e exige AR, PT e profissional habilitado. Sétimo: EPIs dielétricos são obrigatórios e devem ser inspecionados. Oitavo: ferramentas devem ser dielétricas e dentro do prazo de validade. Nono: reciclagem obrigatória a cada dois anos. Décimo: exercite o Direito de Recusa quando houver risco grave e iminente.</a:t>
             </a:r>
           </a:p>
         </p:txBody>
@@ -651,7 +1006,7 @@
           <a:lstStyle/>
           <a:p>
             <a:r>
-              <a:t>A NR-10 se aplica a todas as empresas e trabalhadores que lidem, direta ou indiretamente, com instalações elétricas. Não é uma norma exclusiva para eletricistas — qualquer pessoa que possa se expor a riscos elétricos precisa conhecê-la. Sua base técnica é a NBR 5410, que rege as instalações de baixa tensão.</a:t>
+              <a:t>A NR-10 não é exclusiva para eletricistas. Ela se aplica a qualquer trabalhador que possa ser exposto a risco elétrico, mesmo que indiretamente. Um pintor que trabalha próximo a fiações expostas, ou um pedreiro em obra com instalações energizadas, também estão sujeitos a esta norma. A NR-10 abrange todas as fases de uma instalação elétrica: desde o projeto até a desmontagem, passando pela operação e manutenção.</a:t>
             </a:r>
           </a:p>
         </p:txBody>
@@ -721,7 +1076,7 @@
           <a:lstStyle/>
           <a:p>
             <a:r>
-              <a:t>A NR-10 define três perfis profissionais. O trabalhador capacitado é treinado para tarefas específicas sem precisar de certificado formal. O qualificado tem certificado profissionalizante. O habilitado vai além: tem registro em conselho de classe como o CREA. O prontuário de instalações é documento obrigatório que comprova conformidade com a norma.</a:t>
+              <a:t>A NR-10 define três perfis profissionais para quem trabalha com eletricidade. O capacitado é treinado por um habilitado ou qualificado para tarefas pontuais e não precisa de registro em conselho. O qualificado concluiu um curso técnico específico e tem certificado profissionalizante, mas também não precisa de registro em conselho. O habilitado é o nível mais alto: além da formação técnica ou superior, possui registro no CREA ou CRT, e pode assinar laudos e projetos. O Prontuário de Instalações é o documento que comprova a conformidade de tudo e é obrigação do empregador mantê-lo atualizado.</a:t>
             </a:r>
           </a:p>
         </p:txBody>
@@ -791,7 +1146,7 @@
           <a:lstStyle/>
           <a:p>
             <a:r>
-              <a:t>Antes de qualquer intervenção em instalação elétrica, é obrigatório seguir os cinco passos da sequência de controle. Primeiro desenergize, depois seccione o trecho, verifique com instrumento que não há tensão — nunca presuma que está desligado — faça o aterramento provisório e por fim sinalize com o sistema LOTO: bloqueio com cadeado e placa de aviso.</a:t>
+              <a:t>O Prontuário de Instalações Elétricas é o documento central exigido pela NR-10. Ele deve conter todos os projetos elétricos, memoriais descritivos, diagramas unifilares e funcionais, laudos técnicos e a Anotação de Responsabilidade Técnica do engenheiro responsável. É obrigação do empregador mantê-lo sempre atualizado e disponível para qualquer fiscalização do Ministério do Trabalho. A ausência ou desatualização do prontuário resulta em autuação imediata.</a:t>
             </a:r>
           </a:p>
         </p:txBody>
@@ -861,7 +1216,7 @@
           <a:lstStyle/>
           <a:p>
             <a:r>
-              <a:t>A NR-10 define zonas ao redor de partes energizadas. A Zona de Risco é a mais perigosa, onde só profissionais habilitados com EPIs adequados podem atuar. A Zona Controlada exige profissional capacitado ou superior. A Zona de Vizinhança permite presença de pessoas informadas dos riscos. Sempre que possível, o trabalho deve ser feito com a instalação desenergizada.</a:t>
+              <a:t>A sequência de controle é o procedimento mais importante da NR-10. Antes de tocar em qualquer instalação elétrica, os cinco passos devem ser cumpridos na ordem exata: desenergizar, seccionar, verificar ausência de tensão, realizar o aterramento provisório e aplicar o sistema LOTO. LOTO significa Lockout e Tagout: bloqueio com cadeado individual e etiqueta de aviso. O passo mais crítico e frequentemente negligenciado é o terceiro: verificar com instrumento calibrado se realmente não há tensão. Nunca presuma que está desenergizado — sempre teste.</a:t>
             </a:r>
           </a:p>
         </p:txBody>
@@ -931,7 +1286,7 @@
           <a:lstStyle/>
           <a:p>
             <a:r>
-              <a:t>Trabalhar em instalações energizadas é exceção e exige autorização formal. Antes de iniciar, é preciso elaborar a Análise de Risco e emitir a Permissão de Trabalho. O serviço deve ser executado por profissional habilitado, com mais um capacitado presente. Os equipamentos de proteção dielétricos são obrigatórios e as ferramentas devem estar isoladas e dentro do prazo de validade do teste.</a:t>
+              <a:t>O sistema LOTO é um procedimento de segurança crítico que evita a reenergização acidental de um circuito enquanto alguém está trabalhando nele. O Lockout é o bloqueio físico com cadeado individual — cada trabalhador usa o seu próprio, e ninguém pode remover o cadeado de outra pessoa. O Tagout é a etiqueta de aviso com o nome do responsável e a instrução de não ligar. Quando múltiplos trabalhadores atuam no mesmo ponto, cada um coloca seu próprio cadeado, e o circuito só pode ser reenergizado quando o último cadeado for removido.</a:t>
             </a:r>
           </a:p>
         </p:txBody>
@@ -1001,7 +1356,7 @@
           <a:lstStyle/>
           <a:p>
             <a:r>
-              <a:t>Os EPIs para trabalho elétrico são determinados pela NR-06 em conjunto com a NR-10. As luvas dielétricas devem ser classificadas pela classe de tensão e inspecionadas antes de cada uso. O capacete classe B protege até vinte mil volts. O calçado deve ter solado dielétrico e o uniforme deve ser anti-chama, pois tecidos sintéticos derretem e grudam na pele em caso de arco elétrico.</a:t>
+              <a:t>A NR-10 é clara: o trabalho em instalação energizada é exceção, nunca a regra. A desenergização com os cinco passos deve ser sempre a primeira opção. O trabalho energizado só é permitido quando a desenergização for comprovadamente inviável ou oferecer risco maior que o próprio trabalho. Neste caso, é obrigatório elaborar a Análise de Risco por escrito e emitir a Permissão de Trabalho antes de iniciar qualquer atividade. O serviço deve ser executado por profissional habilitado acompanhado de ao menos mais um trabalhador capacitado.</a:t>
             </a:r>
           </a:p>
         </p:txBody>
@@ -1071,7 +1426,7 @@
           <a:lstStyle/>
           <a:p>
             <a:r>
-              <a:t>É importante entender a diferença entre a NR-10 e as normas técnicas da ABNT. A NR-10 é uma norma trabalhista que protege a integridade do trabalhador. A NBR 5410 é uma norma técnica que define como projetar e executar instalações elétricas de baixa tensão. Ambas se complementam: a norma técnica garante a instalação segura e a NR-10 garante que quem trabalha nela esteja protegido.</a:t>
+              <a:t>A Análise de Risco e a Permissão de Trabalho são documentos distintos e complementares. A AR é elaborada antes, identificando os perigos específicos daquela instalação e definindo os controles necessários. A PT é o documento formal que autoriza o início do trabalho. Ela deve conter todos os dados do serviço, os riscos identificados, os EPIs requeridos, os responsáveis envolvidos e as assinaturas de todos. A PT é válida apenas para aquele serviço específico e deve ser encerrada formalmente ao final da atividade.</a:t>
             </a:r>
           </a:p>
         </p:txBody>
@@ -1141,7 +1496,7 @@
           <a:lstStyle/>
           <a:p>
             <a:r>
-              <a:t>A NR-10 estabelece responsabilidades claras para empregadores e trabalhadores. O empregador deve fornecer ambiente seguro, EPIs gratuitos e treinamentos periódicos a cada dois anos. O trabalhador deve seguir os procedimentos, usar os EPIs e pode exercer o direito de recusa quando houver risco grave e iminente sem sofrer penalidades. O descumprimento por parte do empregador sujeita à multa, embargo e interdição.</a:t>
+              <a:t>A NR-10 define zonas de trabalho ao redor de partes energizadas de uma instalação. A Zona de Risco é a mais próxima das partes vivas, onde o contato acidental é muito provável. Apenas habilitados com EPIs dielétricos podem atuar nela. A Zona Controlada fica ao redor da Zona de Risco e o acesso é restrito a pessoal autorizado e qualificado. A Zona de Vizinhança é a mais afastada, onde pessoas não autorizadas podem estar presentes desde que informadas dos riscos. As distâncias exatas de cada zona variam conforme o nível de tensão da instalação.</a:t>
             </a:r>
           </a:p>
         </p:txBody>
@@ -4155,8 +4510,8 @@
         </p:nvSpPr>
         <p:spPr>
           <a:xfrm>
-            <a:off x="548640" y="1828800"/>
-            <a:ext cx="11091672" cy="1371600"/>
+            <a:off x="548640" y="1645920"/>
+            <a:ext cx="11091672" cy="1645920"/>
           </a:xfrm>
           <a:prstGeom prst="rect">
             <a:avLst/>
@@ -4176,7 +4531,18 @@
                   <a:srgbClr val="1A56DB"/>
                 </a:solidFill>
               </a:rPr>
-              <a:t>NR-10 — Segurança em Instalações e Serviços em Eletricidade</a:t>
+              <a:t>NR-10 — Segurança em Instalações</a:t>
+            </a:r>
+          </a:p>
+          <a:p>
+            <a:pPr algn="ctr"/>
+            <a:r>
+              <a:rPr sz="4000" b="1">
+                <a:solidFill>
+                  <a:srgbClr val="1A56DB"/>
+                </a:solidFill>
+              </a:rPr>
+              <a:t>e Serviços em Eletricidade</a:t>
             </a:r>
           </a:p>
         </p:txBody>
@@ -4189,8 +4555,8 @@
         </p:nvSpPr>
         <p:spPr>
           <a:xfrm>
-            <a:off x="548640" y="3383280"/>
-            <a:ext cx="11091672" cy="502920"/>
+            <a:off x="548640" y="3474720"/>
+            <a:ext cx="11091672" cy="548640"/>
           </a:xfrm>
           <a:prstGeom prst="rect">
             <a:avLst/>
@@ -4223,8 +4589,8 @@
         </p:nvSpPr>
         <p:spPr>
           <a:xfrm>
-            <a:off x="548640" y="3886200"/>
-            <a:ext cx="11091672" cy="502920"/>
+            <a:off x="548640" y="4023360"/>
+            <a:ext cx="11091672" cy="548640"/>
           </a:xfrm>
           <a:prstGeom prst="rect">
             <a:avLst/>
@@ -4296,7 +4662,7 @@
                   <a:srgbClr val="1A56DB"/>
                 </a:solidFill>
               </a:rPr>
-              <a:t>Resumo — Pontos Essenciais da NR-10</a:t>
+              <a:t>Riscos Elétricos — Reconhecer para Prevenir</a:t>
             </a:r>
           </a:p>
         </p:txBody>
@@ -4330,7 +4696,7 @@
                   <a:srgbClr val="111827"/>
                 </a:solidFill>
               </a:rPr>
-              <a:t>✅ Aplica-se a TODOS expostos a riscos elétricos, não só eletricistas.</a:t>
+              <a:t>CHOQUE ELÉTRICO: passagem de corrente pelo corpo humano.</a:t>
             </a:r>
           </a:p>
         </p:txBody>
@@ -4364,7 +4730,7 @@
                   <a:srgbClr val="111827"/>
                 </a:solidFill>
               </a:rPr>
-              <a:t>✅ 3 perfis: Capacitado (treinado) → Qualificado (certificado) → Habilitado (CREA).</a:t>
+              <a:t>   Efeitos: desde formigamento (1 mA) até fibrilação cardíaca (&gt; 50 mA) e morte.</a:t>
             </a:r>
           </a:p>
         </p:txBody>
@@ -4398,7 +4764,7 @@
                   <a:srgbClr val="111827"/>
                 </a:solidFill>
               </a:rPr>
-              <a:t>✅ 5 passos: Desenergizar → Seccionar → Verificar tensão → Aterrar → Sinalizar.</a:t>
+              <a:t>ARCO ELÉTRICO: descarga elétrica no ar entre condutores — temperatura &gt; 20.000°C.</a:t>
             </a:r>
           </a:p>
         </p:txBody>
@@ -4432,7 +4798,7 @@
                   <a:srgbClr val="111827"/>
                 </a:solidFill>
               </a:rPr>
-              <a:t>✅ NUNCA presuma que está desenergizado — teste sempre com instrumento.</a:t>
+              <a:t>   Projeta partículas incandescentes e emite radiação UV intensa.</a:t>
             </a:r>
           </a:p>
         </p:txBody>
@@ -4466,7 +4832,7 @@
                   <a:srgbClr val="111827"/>
                 </a:solidFill>
               </a:rPr>
-              <a:t>✅ Trabalho energizado é EXCEÇÃO: exige AR, PT, habilitado e EPIs dielétricos.</a:t>
+              <a:t>QUEIMADURAS: por contato, por arco ou por ignição do vestuário.</a:t>
             </a:r>
           </a:p>
         </p:txBody>
@@ -4500,7 +4866,1593 @@
                   <a:srgbClr val="111827"/>
                 </a:solidFill>
               </a:rPr>
-              <a:t>✅ Reciclagem obrigatória a CADA 2 ANOS ou quando houver mudança de risco.</a:t>
+              <a:t>INCÊNDIO: arco ou superaquecimento podem inflamar materiais próximos.</a:t>
+            </a:r>
+          </a:p>
+        </p:txBody>
+      </p:sp>
+      <p:sp>
+        <p:nvSpPr>
+          <p:cNvPr id="9" name="TextBox 8"/>
+          <p:cNvSpPr txBox="1"/>
+          <p:nvPr/>
+        </p:nvSpPr>
+        <p:spPr>
+          <a:xfrm>
+            <a:off x="548640" y="4325112"/>
+            <a:ext cx="11091672" cy="548640"/>
+          </a:xfrm>
+          <a:prstGeom prst="rect">
+            <a:avLst/>
+          </a:prstGeom>
+          <a:noFill/>
+        </p:spPr>
+        <p:txBody>
+          <a:bodyPr wrap="square">
+            <a:spAutoFit/>
+          </a:bodyPr>
+          <a:lstStyle/>
+          <a:p>
+            <a:pPr algn="l"/>
+            <a:r>
+              <a:rPr sz="1800" b="0">
+                <a:solidFill>
+                  <a:srgbClr val="111827"/>
+                </a:solidFill>
+              </a:rPr>
+              <a:t>TENSÃO DE PASSO: diferença de potencial no solo (fio caído) — afastar em passos curtos.</a:t>
+            </a:r>
+          </a:p>
+        </p:txBody>
+      </p:sp>
+    </p:spTree>
+  </p:cSld>
+  <p:clrMapOvr>
+    <a:masterClrMapping/>
+  </p:clrMapOvr>
+</p:sld>
+</file>
+
+<file path=ppt/slides/slide11.xml><?xml version="1.0" encoding="utf-8"?>
+<p:sld xmlns:a="http://schemas.openxmlformats.org/drawingml/2006/main" xmlns:p="http://schemas.openxmlformats.org/presentationml/2006/main" xmlns:r="http://schemas.openxmlformats.org/officeDocument/2006/relationships">
+  <p:cSld>
+    <p:spTree>
+      <p:nvGrpSpPr>
+        <p:cNvPr id="1" name=""/>
+        <p:cNvGrpSpPr/>
+        <p:nvPr/>
+      </p:nvGrpSpPr>
+      <p:grpSpPr/>
+      <p:sp>
+        <p:nvSpPr>
+          <p:cNvPr id="2" name="TextBox 1"/>
+          <p:cNvSpPr txBox="1"/>
+          <p:nvPr/>
+        </p:nvSpPr>
+        <p:spPr>
+          <a:xfrm>
+            <a:off x="548640" y="228600"/>
+            <a:ext cx="11091672" cy="822960"/>
+          </a:xfrm>
+          <a:prstGeom prst="rect">
+            <a:avLst/>
+          </a:prstGeom>
+          <a:noFill/>
+        </p:spPr>
+        <p:txBody>
+          <a:bodyPr wrap="square">
+            <a:spAutoFit/>
+          </a:bodyPr>
+          <a:lstStyle/>
+          <a:p>
+            <a:pPr algn="l"/>
+            <a:r>
+              <a:rPr sz="2600" b="1">
+                <a:solidFill>
+                  <a:srgbClr val="1A56DB"/>
+                </a:solidFill>
+              </a:rPr>
+              <a:t>EPIs Obrigatórios para Trabalho Elétrico (NR-06 + NR-10)</a:t>
+            </a:r>
+          </a:p>
+        </p:txBody>
+      </p:sp>
+      <p:sp>
+        <p:nvSpPr>
+          <p:cNvPr id="3" name="TextBox 2"/>
+          <p:cNvSpPr txBox="1"/>
+          <p:nvPr/>
+        </p:nvSpPr>
+        <p:spPr>
+          <a:xfrm>
+            <a:off x="548640" y="1143000"/>
+            <a:ext cx="11091672" cy="548640"/>
+          </a:xfrm>
+          <a:prstGeom prst="rect">
+            <a:avLst/>
+          </a:prstGeom>
+          <a:noFill/>
+        </p:spPr>
+        <p:txBody>
+          <a:bodyPr wrap="square">
+            <a:spAutoFit/>
+          </a:bodyPr>
+          <a:lstStyle/>
+          <a:p>
+            <a:pPr algn="l"/>
+            <a:r>
+              <a:rPr sz="1800" b="0">
+                <a:solidFill>
+                  <a:srgbClr val="111827"/>
+                </a:solidFill>
+              </a:rPr>
+              <a:t>LUVAS DIELETRICAS: classificadas por classe de tensão (Classe 0 a 4).</a:t>
+            </a:r>
+          </a:p>
+        </p:txBody>
+      </p:sp>
+      <p:sp>
+        <p:nvSpPr>
+          <p:cNvPr id="4" name="TextBox 3"/>
+          <p:cNvSpPr txBox="1"/>
+          <p:nvPr/>
+        </p:nvSpPr>
+        <p:spPr>
+          <a:xfrm>
+            <a:off x="548640" y="1673352"/>
+            <a:ext cx="11091672" cy="548640"/>
+          </a:xfrm>
+          <a:prstGeom prst="rect">
+            <a:avLst/>
+          </a:prstGeom>
+          <a:noFill/>
+        </p:spPr>
+        <p:txBody>
+          <a:bodyPr wrap="square">
+            <a:spAutoFit/>
+          </a:bodyPr>
+          <a:lstStyle/>
+          <a:p>
+            <a:pPr algn="l"/>
+            <a:r>
+              <a:rPr sz="1800" b="0">
+                <a:solidFill>
+                  <a:srgbClr val="111827"/>
+                </a:solidFill>
+              </a:rPr>
+              <a:t>   Inspecionar ANTES de cada uso: enrolar do punho à ponta verificando furos.</a:t>
+            </a:r>
+          </a:p>
+        </p:txBody>
+      </p:sp>
+      <p:sp>
+        <p:nvSpPr>
+          <p:cNvPr id="5" name="TextBox 4"/>
+          <p:cNvSpPr txBox="1"/>
+          <p:nvPr/>
+        </p:nvSpPr>
+        <p:spPr>
+          <a:xfrm>
+            <a:off x="548640" y="2203704"/>
+            <a:ext cx="11091672" cy="548640"/>
+          </a:xfrm>
+          <a:prstGeom prst="rect">
+            <a:avLst/>
+          </a:prstGeom>
+          <a:noFill/>
+        </p:spPr>
+        <p:txBody>
+          <a:bodyPr wrap="square">
+            <a:spAutoFit/>
+          </a:bodyPr>
+          <a:lstStyle/>
+          <a:p>
+            <a:pPr algn="l"/>
+            <a:r>
+              <a:rPr sz="1800" b="0">
+                <a:solidFill>
+                  <a:srgbClr val="111827"/>
+                </a:solidFill>
+              </a:rPr>
+              <a:t>CAPACETE CLASSE B: isolante até 20.000 V. Com jugular obrigatório.</a:t>
+            </a:r>
+          </a:p>
+        </p:txBody>
+      </p:sp>
+      <p:sp>
+        <p:nvSpPr>
+          <p:cNvPr id="6" name="TextBox 5"/>
+          <p:cNvSpPr txBox="1"/>
+          <p:nvPr/>
+        </p:nvSpPr>
+        <p:spPr>
+          <a:xfrm>
+            <a:off x="548640" y="2734056"/>
+            <a:ext cx="11091672" cy="548640"/>
+          </a:xfrm>
+          <a:prstGeom prst="rect">
+            <a:avLst/>
+          </a:prstGeom>
+          <a:noFill/>
+        </p:spPr>
+        <p:txBody>
+          <a:bodyPr wrap="square">
+            <a:spAutoFit/>
+          </a:bodyPr>
+          <a:lstStyle/>
+          <a:p>
+            <a:pPr algn="l"/>
+            <a:r>
+              <a:rPr sz="1800" b="0">
+                <a:solidFill>
+                  <a:srgbClr val="111827"/>
+                </a:solidFill>
+              </a:rPr>
+              <a:t>OCULOS DE PROTEÇÃO: contra arco elétrico e projeção de partículas.</a:t>
+            </a:r>
+          </a:p>
+        </p:txBody>
+      </p:sp>
+      <p:sp>
+        <p:nvSpPr>
+          <p:cNvPr id="7" name="TextBox 6"/>
+          <p:cNvSpPr txBox="1"/>
+          <p:nvPr/>
+        </p:nvSpPr>
+        <p:spPr>
+          <a:xfrm>
+            <a:off x="548640" y="3264408"/>
+            <a:ext cx="11091672" cy="548640"/>
+          </a:xfrm>
+          <a:prstGeom prst="rect">
+            <a:avLst/>
+          </a:prstGeom>
+          <a:noFill/>
+        </p:spPr>
+        <p:txBody>
+          <a:bodyPr wrap="square">
+            <a:spAutoFit/>
+          </a:bodyPr>
+          <a:lstStyle/>
+          <a:p>
+            <a:pPr algn="l"/>
+            <a:r>
+              <a:rPr sz="1800" b="0">
+                <a:solidFill>
+                  <a:srgbClr val="111827"/>
+                </a:solidFill>
+              </a:rPr>
+              <a:t>CALCADO DIELETRICO: solado isolante, sem partes metálicas expostas.</a:t>
+            </a:r>
+          </a:p>
+        </p:txBody>
+      </p:sp>
+      <p:sp>
+        <p:nvSpPr>
+          <p:cNvPr id="8" name="TextBox 7"/>
+          <p:cNvSpPr txBox="1"/>
+          <p:nvPr/>
+        </p:nvSpPr>
+        <p:spPr>
+          <a:xfrm>
+            <a:off x="548640" y="3794760"/>
+            <a:ext cx="11091672" cy="548640"/>
+          </a:xfrm>
+          <a:prstGeom prst="rect">
+            <a:avLst/>
+          </a:prstGeom>
+          <a:noFill/>
+        </p:spPr>
+        <p:txBody>
+          <a:bodyPr wrap="square">
+            <a:spAutoFit/>
+          </a:bodyPr>
+          <a:lstStyle/>
+          <a:p>
+            <a:pPr algn="l"/>
+            <a:r>
+              <a:rPr sz="1800" b="0">
+                <a:solidFill>
+                  <a:srgbClr val="111827"/>
+                </a:solidFill>
+              </a:rPr>
+              <a:t>UNIFORME ANTI-CHAMA (FR): tecido tratado — proibido qualquer sintético.</a:t>
+            </a:r>
+          </a:p>
+        </p:txBody>
+      </p:sp>
+      <p:sp>
+        <p:nvSpPr>
+          <p:cNvPr id="9" name="TextBox 8"/>
+          <p:cNvSpPr txBox="1"/>
+          <p:nvPr/>
+        </p:nvSpPr>
+        <p:spPr>
+          <a:xfrm>
+            <a:off x="548640" y="4325112"/>
+            <a:ext cx="11091672" cy="548640"/>
+          </a:xfrm>
+          <a:prstGeom prst="rect">
+            <a:avLst/>
+          </a:prstGeom>
+          <a:noFill/>
+        </p:spPr>
+        <p:txBody>
+          <a:bodyPr wrap="square">
+            <a:spAutoFit/>
+          </a:bodyPr>
+          <a:lstStyle/>
+          <a:p>
+            <a:pPr algn="l"/>
+            <a:r>
+              <a:rPr sz="1800" b="0">
+                <a:solidFill>
+                  <a:srgbClr val="111827"/>
+                </a:solidFill>
+              </a:rPr>
+              <a:t>MANGA PROTETORA: usada com a luva dielétrica para proteção do antebraço.</a:t>
+            </a:r>
+          </a:p>
+        </p:txBody>
+      </p:sp>
+    </p:spTree>
+  </p:cSld>
+  <p:clrMapOvr>
+    <a:masterClrMapping/>
+  </p:clrMapOvr>
+</p:sld>
+</file>
+
+<file path=ppt/slides/slide12.xml><?xml version="1.0" encoding="utf-8"?>
+<p:sld xmlns:a="http://schemas.openxmlformats.org/drawingml/2006/main" xmlns:p="http://schemas.openxmlformats.org/presentationml/2006/main" xmlns:r="http://schemas.openxmlformats.org/officeDocument/2006/relationships">
+  <p:cSld>
+    <p:spTree>
+      <p:nvGrpSpPr>
+        <p:cNvPr id="1" name=""/>
+        <p:cNvGrpSpPr/>
+        <p:nvPr/>
+      </p:nvGrpSpPr>
+      <p:grpSpPr/>
+      <p:sp>
+        <p:nvSpPr>
+          <p:cNvPr id="2" name="TextBox 1"/>
+          <p:cNvSpPr txBox="1"/>
+          <p:nvPr/>
+        </p:nvSpPr>
+        <p:spPr>
+          <a:xfrm>
+            <a:off x="548640" y="228600"/>
+            <a:ext cx="11091672" cy="822960"/>
+          </a:xfrm>
+          <a:prstGeom prst="rect">
+            <a:avLst/>
+          </a:prstGeom>
+          <a:noFill/>
+        </p:spPr>
+        <p:txBody>
+          <a:bodyPr wrap="square">
+            <a:spAutoFit/>
+          </a:bodyPr>
+          <a:lstStyle/>
+          <a:p>
+            <a:pPr algn="l"/>
+            <a:r>
+              <a:rPr sz="2600" b="1">
+                <a:solidFill>
+                  <a:srgbClr val="1A56DB"/>
+                </a:solidFill>
+              </a:rPr>
+              <a:t>Ferramentas Dielétricas</a:t>
+            </a:r>
+          </a:p>
+        </p:txBody>
+      </p:sp>
+      <p:sp>
+        <p:nvSpPr>
+          <p:cNvPr id="3" name="TextBox 2"/>
+          <p:cNvSpPr txBox="1"/>
+          <p:nvPr/>
+        </p:nvSpPr>
+        <p:spPr>
+          <a:xfrm>
+            <a:off x="548640" y="1143000"/>
+            <a:ext cx="11091672" cy="548640"/>
+          </a:xfrm>
+          <a:prstGeom prst="rect">
+            <a:avLst/>
+          </a:prstGeom>
+          <a:noFill/>
+        </p:spPr>
+        <p:txBody>
+          <a:bodyPr wrap="square">
+            <a:spAutoFit/>
+          </a:bodyPr>
+          <a:lstStyle/>
+          <a:p>
+            <a:pPr algn="l"/>
+            <a:r>
+              <a:rPr sz="1800" b="0">
+                <a:solidFill>
+                  <a:srgbClr val="111827"/>
+                </a:solidFill>
+              </a:rPr>
+              <a:t>• Ferramentas com cabo e/ou corpo isolado para uso em instalações elétricas.</a:t>
+            </a:r>
+          </a:p>
+        </p:txBody>
+      </p:sp>
+      <p:sp>
+        <p:nvSpPr>
+          <p:cNvPr id="4" name="TextBox 3"/>
+          <p:cNvSpPr txBox="1"/>
+          <p:nvPr/>
+        </p:nvSpPr>
+        <p:spPr>
+          <a:xfrm>
+            <a:off x="548640" y="1673352"/>
+            <a:ext cx="11091672" cy="548640"/>
+          </a:xfrm>
+          <a:prstGeom prst="rect">
+            <a:avLst/>
+          </a:prstGeom>
+          <a:noFill/>
+        </p:spPr>
+        <p:txBody>
+          <a:bodyPr wrap="square">
+            <a:spAutoFit/>
+          </a:bodyPr>
+          <a:lstStyle/>
+          <a:p>
+            <a:pPr algn="l"/>
+            <a:r>
+              <a:rPr sz="1800" b="0">
+                <a:solidFill>
+                  <a:srgbClr val="111827"/>
+                </a:solidFill>
+              </a:rPr>
+              <a:t>• Classificadas por tensão máxima de trabalho: 1.000 V CA / 1.500 V CC.</a:t>
+            </a:r>
+          </a:p>
+        </p:txBody>
+      </p:sp>
+      <p:sp>
+        <p:nvSpPr>
+          <p:cNvPr id="5" name="TextBox 4"/>
+          <p:cNvSpPr txBox="1"/>
+          <p:nvPr/>
+        </p:nvSpPr>
+        <p:spPr>
+          <a:xfrm>
+            <a:off x="548640" y="2203704"/>
+            <a:ext cx="11091672" cy="548640"/>
+          </a:xfrm>
+          <a:prstGeom prst="rect">
+            <a:avLst/>
+          </a:prstGeom>
+          <a:noFill/>
+        </p:spPr>
+        <p:txBody>
+          <a:bodyPr wrap="square">
+            <a:spAutoFit/>
+          </a:bodyPr>
+          <a:lstStyle/>
+          <a:p>
+            <a:pPr algn="l"/>
+            <a:r>
+              <a:rPr sz="1800" b="0">
+                <a:solidFill>
+                  <a:srgbClr val="111827"/>
+                </a:solidFill>
+              </a:rPr>
+              <a:t>• Regulamentadas pela NBR IEC 60900.</a:t>
+            </a:r>
+          </a:p>
+        </p:txBody>
+      </p:sp>
+      <p:sp>
+        <p:nvSpPr>
+          <p:cNvPr id="6" name="TextBox 5"/>
+          <p:cNvSpPr txBox="1"/>
+          <p:nvPr/>
+        </p:nvSpPr>
+        <p:spPr>
+          <a:xfrm>
+            <a:off x="548640" y="2734056"/>
+            <a:ext cx="11091672" cy="548640"/>
+          </a:xfrm>
+          <a:prstGeom prst="rect">
+            <a:avLst/>
+          </a:prstGeom>
+          <a:noFill/>
+        </p:spPr>
+        <p:txBody>
+          <a:bodyPr wrap="square">
+            <a:spAutoFit/>
+          </a:bodyPr>
+          <a:lstStyle/>
+          <a:p>
+            <a:pPr algn="l"/>
+            <a:r>
+              <a:rPr sz="1800" b="0">
+                <a:solidFill>
+                  <a:srgbClr val="111827"/>
+                </a:solidFill>
+              </a:rPr>
+              <a:t>• Inspeção obrigatória antes de cada uso: verificar trincas, desgaste e integridade.</a:t>
+            </a:r>
+          </a:p>
+        </p:txBody>
+      </p:sp>
+      <p:sp>
+        <p:nvSpPr>
+          <p:cNvPr id="7" name="TextBox 6"/>
+          <p:cNvSpPr txBox="1"/>
+          <p:nvPr/>
+        </p:nvSpPr>
+        <p:spPr>
+          <a:xfrm>
+            <a:off x="548640" y="3264408"/>
+            <a:ext cx="11091672" cy="548640"/>
+          </a:xfrm>
+          <a:prstGeom prst="rect">
+            <a:avLst/>
+          </a:prstGeom>
+          <a:noFill/>
+        </p:spPr>
+        <p:txBody>
+          <a:bodyPr wrap="square">
+            <a:spAutoFit/>
+          </a:bodyPr>
+          <a:lstStyle/>
+          <a:p>
+            <a:pPr algn="l"/>
+            <a:r>
+              <a:rPr sz="1800" b="0">
+                <a:solidFill>
+                  <a:srgbClr val="111827"/>
+                </a:solidFill>
+              </a:rPr>
+              <a:t>• Validade de teste dielétrico: respeitar o prazo impresso na ferramenta.</a:t>
+            </a:r>
+          </a:p>
+        </p:txBody>
+      </p:sp>
+      <p:sp>
+        <p:nvSpPr>
+          <p:cNvPr id="8" name="TextBox 7"/>
+          <p:cNvSpPr txBox="1"/>
+          <p:nvPr/>
+        </p:nvSpPr>
+        <p:spPr>
+          <a:xfrm>
+            <a:off x="548640" y="3794760"/>
+            <a:ext cx="11091672" cy="548640"/>
+          </a:xfrm>
+          <a:prstGeom prst="rect">
+            <a:avLst/>
+          </a:prstGeom>
+          <a:noFill/>
+        </p:spPr>
+        <p:txBody>
+          <a:bodyPr wrap="square">
+            <a:spAutoFit/>
+          </a:bodyPr>
+          <a:lstStyle/>
+          <a:p>
+            <a:pPr algn="l"/>
+            <a:r>
+              <a:rPr sz="1800" b="0">
+                <a:solidFill>
+                  <a:srgbClr val="111827"/>
+                </a:solidFill>
+              </a:rPr>
+              <a:t>• Ferramentas com isolamento danificado devem ser RETIRADAS DE USO imediatamente.</a:t>
+            </a:r>
+          </a:p>
+        </p:txBody>
+      </p:sp>
+      <p:sp>
+        <p:nvSpPr>
+          <p:cNvPr id="9" name="TextBox 8"/>
+          <p:cNvSpPr txBox="1"/>
+          <p:nvPr/>
+        </p:nvSpPr>
+        <p:spPr>
+          <a:xfrm>
+            <a:off x="548640" y="4325112"/>
+            <a:ext cx="11091672" cy="548640"/>
+          </a:xfrm>
+          <a:prstGeom prst="rect">
+            <a:avLst/>
+          </a:prstGeom>
+          <a:noFill/>
+        </p:spPr>
+        <p:txBody>
+          <a:bodyPr wrap="square">
+            <a:spAutoFit/>
+          </a:bodyPr>
+          <a:lstStyle/>
+          <a:p>
+            <a:pPr algn="l"/>
+            <a:r>
+              <a:rPr sz="1800" b="0">
+                <a:solidFill>
+                  <a:srgbClr val="111827"/>
+                </a:solidFill>
+              </a:rPr>
+              <a:t>• Nunca use ferramentas convencionais (não isoladas) em instalações energizadas.</a:t>
+            </a:r>
+          </a:p>
+        </p:txBody>
+      </p:sp>
+    </p:spTree>
+  </p:cSld>
+  <p:clrMapOvr>
+    <a:masterClrMapping/>
+  </p:clrMapOvr>
+</p:sld>
+</file>
+
+<file path=ppt/slides/slide13.xml><?xml version="1.0" encoding="utf-8"?>
+<p:sld xmlns:a="http://schemas.openxmlformats.org/drawingml/2006/main" xmlns:p="http://schemas.openxmlformats.org/presentationml/2006/main" xmlns:r="http://schemas.openxmlformats.org/officeDocument/2006/relationships">
+  <p:cSld>
+    <p:spTree>
+      <p:nvGrpSpPr>
+        <p:cNvPr id="1" name=""/>
+        <p:cNvGrpSpPr/>
+        <p:nvPr/>
+      </p:nvGrpSpPr>
+      <p:grpSpPr/>
+      <p:sp>
+        <p:nvSpPr>
+          <p:cNvPr id="2" name="TextBox 1"/>
+          <p:cNvSpPr txBox="1"/>
+          <p:nvPr/>
+        </p:nvSpPr>
+        <p:spPr>
+          <a:xfrm>
+            <a:off x="548640" y="228600"/>
+            <a:ext cx="11091672" cy="822960"/>
+          </a:xfrm>
+          <a:prstGeom prst="rect">
+            <a:avLst/>
+          </a:prstGeom>
+          <a:noFill/>
+        </p:spPr>
+        <p:txBody>
+          <a:bodyPr wrap="square">
+            <a:spAutoFit/>
+          </a:bodyPr>
+          <a:lstStyle/>
+          <a:p>
+            <a:pPr algn="l"/>
+            <a:r>
+              <a:rPr sz="2600" b="1">
+                <a:solidFill>
+                  <a:srgbClr val="1A56DB"/>
+                </a:solidFill>
+              </a:rPr>
+              <a:t>Responsabilidades do Empregador (NR-10)</a:t>
+            </a:r>
+          </a:p>
+        </p:txBody>
+      </p:sp>
+      <p:sp>
+        <p:nvSpPr>
+          <p:cNvPr id="3" name="TextBox 2"/>
+          <p:cNvSpPr txBox="1"/>
+          <p:nvPr/>
+        </p:nvSpPr>
+        <p:spPr>
+          <a:xfrm>
+            <a:off x="548640" y="1143000"/>
+            <a:ext cx="11091672" cy="548640"/>
+          </a:xfrm>
+          <a:prstGeom prst="rect">
+            <a:avLst/>
+          </a:prstGeom>
+          <a:noFill/>
+        </p:spPr>
+        <p:txBody>
+          <a:bodyPr wrap="square">
+            <a:spAutoFit/>
+          </a:bodyPr>
+          <a:lstStyle/>
+          <a:p>
+            <a:pPr algn="l"/>
+            <a:r>
+              <a:rPr sz="1800" b="0">
+                <a:solidFill>
+                  <a:srgbClr val="111827"/>
+                </a:solidFill>
+              </a:rPr>
+              <a:t>• Garantir que as instalações elétricas sejam seguras e estejam em conformidade.</a:t>
+            </a:r>
+          </a:p>
+        </p:txBody>
+      </p:sp>
+      <p:sp>
+        <p:nvSpPr>
+          <p:cNvPr id="4" name="TextBox 3"/>
+          <p:cNvSpPr txBox="1"/>
+          <p:nvPr/>
+        </p:nvSpPr>
+        <p:spPr>
+          <a:xfrm>
+            <a:off x="548640" y="1673352"/>
+            <a:ext cx="11091672" cy="548640"/>
+          </a:xfrm>
+          <a:prstGeom prst="rect">
+            <a:avLst/>
+          </a:prstGeom>
+          <a:noFill/>
+        </p:spPr>
+        <p:txBody>
+          <a:bodyPr wrap="square">
+            <a:spAutoFit/>
+          </a:bodyPr>
+          <a:lstStyle/>
+          <a:p>
+            <a:pPr algn="l"/>
+            <a:r>
+              <a:rPr sz="1800" b="0">
+                <a:solidFill>
+                  <a:srgbClr val="111827"/>
+                </a:solidFill>
+              </a:rPr>
+              <a:t>• Manter o Prontuário de Instalações atualizado e disponível.</a:t>
+            </a:r>
+          </a:p>
+        </p:txBody>
+      </p:sp>
+      <p:sp>
+        <p:nvSpPr>
+          <p:cNvPr id="5" name="TextBox 4"/>
+          <p:cNvSpPr txBox="1"/>
+          <p:nvPr/>
+        </p:nvSpPr>
+        <p:spPr>
+          <a:xfrm>
+            <a:off x="548640" y="2203704"/>
+            <a:ext cx="11091672" cy="548640"/>
+          </a:xfrm>
+          <a:prstGeom prst="rect">
+            <a:avLst/>
+          </a:prstGeom>
+          <a:noFill/>
+        </p:spPr>
+        <p:txBody>
+          <a:bodyPr wrap="square">
+            <a:spAutoFit/>
+          </a:bodyPr>
+          <a:lstStyle/>
+          <a:p>
+            <a:pPr algn="l"/>
+            <a:r>
+              <a:rPr sz="1800" b="0">
+                <a:solidFill>
+                  <a:srgbClr val="111827"/>
+                </a:solidFill>
+              </a:rPr>
+              <a:t>• Fornecer EPIs dielétricos gratuitamente e em quantidade suficiente.</a:t>
+            </a:r>
+          </a:p>
+        </p:txBody>
+      </p:sp>
+      <p:sp>
+        <p:nvSpPr>
+          <p:cNvPr id="6" name="TextBox 5"/>
+          <p:cNvSpPr txBox="1"/>
+          <p:nvPr/>
+        </p:nvSpPr>
+        <p:spPr>
+          <a:xfrm>
+            <a:off x="548640" y="2734056"/>
+            <a:ext cx="11091672" cy="548640"/>
+          </a:xfrm>
+          <a:prstGeom prst="rect">
+            <a:avLst/>
+          </a:prstGeom>
+          <a:noFill/>
+        </p:spPr>
+        <p:txBody>
+          <a:bodyPr wrap="square">
+            <a:spAutoFit/>
+          </a:bodyPr>
+          <a:lstStyle/>
+          <a:p>
+            <a:pPr algn="l"/>
+            <a:r>
+              <a:rPr sz="1800" b="0">
+                <a:solidFill>
+                  <a:srgbClr val="111827"/>
+                </a:solidFill>
+              </a:rPr>
+              <a:t>• Promover treinamento NR-10 a CADA 2 ANOS ou quando houver mudança de risco.</a:t>
+            </a:r>
+          </a:p>
+        </p:txBody>
+      </p:sp>
+      <p:sp>
+        <p:nvSpPr>
+          <p:cNvPr id="7" name="TextBox 6"/>
+          <p:cNvSpPr txBox="1"/>
+          <p:nvPr/>
+        </p:nvSpPr>
+        <p:spPr>
+          <a:xfrm>
+            <a:off x="548640" y="3264408"/>
+            <a:ext cx="11091672" cy="548640"/>
+          </a:xfrm>
+          <a:prstGeom prst="rect">
+            <a:avLst/>
+          </a:prstGeom>
+          <a:noFill/>
+        </p:spPr>
+        <p:txBody>
+          <a:bodyPr wrap="square">
+            <a:spAutoFit/>
+          </a:bodyPr>
+          <a:lstStyle/>
+          <a:p>
+            <a:pPr algn="l"/>
+            <a:r>
+              <a:rPr sz="1800" b="0">
+                <a:solidFill>
+                  <a:srgbClr val="111827"/>
+                </a:solidFill>
+              </a:rPr>
+              <a:t>• Garantir que trabalho energizado tenha AR, PT e habilitado responsável.</a:t>
+            </a:r>
+          </a:p>
+        </p:txBody>
+      </p:sp>
+      <p:sp>
+        <p:nvSpPr>
+          <p:cNvPr id="8" name="TextBox 7"/>
+          <p:cNvSpPr txBox="1"/>
+          <p:nvPr/>
+        </p:nvSpPr>
+        <p:spPr>
+          <a:xfrm>
+            <a:off x="548640" y="3794760"/>
+            <a:ext cx="11091672" cy="548640"/>
+          </a:xfrm>
+          <a:prstGeom prst="rect">
+            <a:avLst/>
+          </a:prstGeom>
+          <a:noFill/>
+        </p:spPr>
+        <p:txBody>
+          <a:bodyPr wrap="square">
+            <a:spAutoFit/>
+          </a:bodyPr>
+          <a:lstStyle/>
+          <a:p>
+            <a:pPr algn="l"/>
+            <a:r>
+              <a:rPr sz="1800" b="0">
+                <a:solidFill>
+                  <a:srgbClr val="111827"/>
+                </a:solidFill>
+              </a:rPr>
+              <a:t>• Implementar e manter o sistema LOTO na empresa.</a:t>
+            </a:r>
+          </a:p>
+        </p:txBody>
+      </p:sp>
+      <p:sp>
+        <p:nvSpPr>
+          <p:cNvPr id="9" name="TextBox 8"/>
+          <p:cNvSpPr txBox="1"/>
+          <p:nvPr/>
+        </p:nvSpPr>
+        <p:spPr>
+          <a:xfrm>
+            <a:off x="548640" y="4325112"/>
+            <a:ext cx="11091672" cy="548640"/>
+          </a:xfrm>
+          <a:prstGeom prst="rect">
+            <a:avLst/>
+          </a:prstGeom>
+          <a:noFill/>
+        </p:spPr>
+        <p:txBody>
+          <a:bodyPr wrap="square">
+            <a:spAutoFit/>
+          </a:bodyPr>
+          <a:lstStyle/>
+          <a:p>
+            <a:pPr algn="l"/>
+            <a:r>
+              <a:rPr sz="1800" b="0">
+                <a:solidFill>
+                  <a:srgbClr val="111827"/>
+                </a:solidFill>
+              </a:rPr>
+              <a:t>• Manter registros de todos os treinamentos, inspeções e manutenções.</a:t>
+            </a:r>
+          </a:p>
+        </p:txBody>
+      </p:sp>
+    </p:spTree>
+  </p:cSld>
+  <p:clrMapOvr>
+    <a:masterClrMapping/>
+  </p:clrMapOvr>
+</p:sld>
+</file>
+
+<file path=ppt/slides/slide14.xml><?xml version="1.0" encoding="utf-8"?>
+<p:sld xmlns:a="http://schemas.openxmlformats.org/drawingml/2006/main" xmlns:p="http://schemas.openxmlformats.org/presentationml/2006/main" xmlns:r="http://schemas.openxmlformats.org/officeDocument/2006/relationships">
+  <p:cSld>
+    <p:spTree>
+      <p:nvGrpSpPr>
+        <p:cNvPr id="1" name=""/>
+        <p:cNvGrpSpPr/>
+        <p:nvPr/>
+      </p:nvGrpSpPr>
+      <p:grpSpPr/>
+      <p:sp>
+        <p:nvSpPr>
+          <p:cNvPr id="2" name="TextBox 1"/>
+          <p:cNvSpPr txBox="1"/>
+          <p:nvPr/>
+        </p:nvSpPr>
+        <p:spPr>
+          <a:xfrm>
+            <a:off x="548640" y="228600"/>
+            <a:ext cx="11091672" cy="822960"/>
+          </a:xfrm>
+          <a:prstGeom prst="rect">
+            <a:avLst/>
+          </a:prstGeom>
+          <a:noFill/>
+        </p:spPr>
+        <p:txBody>
+          <a:bodyPr wrap="square">
+            <a:spAutoFit/>
+          </a:bodyPr>
+          <a:lstStyle/>
+          <a:p>
+            <a:pPr algn="l"/>
+            <a:r>
+              <a:rPr sz="2600" b="1">
+                <a:solidFill>
+                  <a:srgbClr val="1A56DB"/>
+                </a:solidFill>
+              </a:rPr>
+              <a:t>Responsabilidades do Trabalhador + Direito de Recusa</a:t>
+            </a:r>
+          </a:p>
+        </p:txBody>
+      </p:sp>
+      <p:sp>
+        <p:nvSpPr>
+          <p:cNvPr id="3" name="TextBox 2"/>
+          <p:cNvSpPr txBox="1"/>
+          <p:nvPr/>
+        </p:nvSpPr>
+        <p:spPr>
+          <a:xfrm>
+            <a:off x="548640" y="1143000"/>
+            <a:ext cx="11091672" cy="548640"/>
+          </a:xfrm>
+          <a:prstGeom prst="rect">
+            <a:avLst/>
+          </a:prstGeom>
+          <a:noFill/>
+        </p:spPr>
+        <p:txBody>
+          <a:bodyPr wrap="square">
+            <a:spAutoFit/>
+          </a:bodyPr>
+          <a:lstStyle/>
+          <a:p>
+            <a:pPr algn="l"/>
+            <a:r>
+              <a:rPr sz="1800" b="0">
+                <a:solidFill>
+                  <a:srgbClr val="111827"/>
+                </a:solidFill>
+              </a:rPr>
+              <a:t>• Seguir rigorosamente a sequência de controle (5 passos) antes de qualquer intervenção.</a:t>
+            </a:r>
+          </a:p>
+        </p:txBody>
+      </p:sp>
+      <p:sp>
+        <p:nvSpPr>
+          <p:cNvPr id="4" name="TextBox 3"/>
+          <p:cNvSpPr txBox="1"/>
+          <p:nvPr/>
+        </p:nvSpPr>
+        <p:spPr>
+          <a:xfrm>
+            <a:off x="548640" y="1673352"/>
+            <a:ext cx="11091672" cy="548640"/>
+          </a:xfrm>
+          <a:prstGeom prst="rect">
+            <a:avLst/>
+          </a:prstGeom>
+          <a:noFill/>
+        </p:spPr>
+        <p:txBody>
+          <a:bodyPr wrap="square">
+            <a:spAutoFit/>
+          </a:bodyPr>
+          <a:lstStyle/>
+          <a:p>
+            <a:pPr algn="l"/>
+            <a:r>
+              <a:rPr sz="1800" b="0">
+                <a:solidFill>
+                  <a:srgbClr val="111827"/>
+                </a:solidFill>
+              </a:rPr>
+              <a:t>• Usar corretamente TODOS os EPIs fornecidos — nunca improvise.</a:t>
+            </a:r>
+          </a:p>
+        </p:txBody>
+      </p:sp>
+      <p:sp>
+        <p:nvSpPr>
+          <p:cNvPr id="5" name="TextBox 4"/>
+          <p:cNvSpPr txBox="1"/>
+          <p:nvPr/>
+        </p:nvSpPr>
+        <p:spPr>
+          <a:xfrm>
+            <a:off x="548640" y="2203704"/>
+            <a:ext cx="11091672" cy="548640"/>
+          </a:xfrm>
+          <a:prstGeom prst="rect">
+            <a:avLst/>
+          </a:prstGeom>
+          <a:noFill/>
+        </p:spPr>
+        <p:txBody>
+          <a:bodyPr wrap="square">
+            <a:spAutoFit/>
+          </a:bodyPr>
+          <a:lstStyle/>
+          <a:p>
+            <a:pPr algn="l"/>
+            <a:r>
+              <a:rPr sz="1800" b="0">
+                <a:solidFill>
+                  <a:srgbClr val="111827"/>
+                </a:solidFill>
+              </a:rPr>
+              <a:t>• NUNCA presumir que a instalação está desenergizada — teste sempre.</a:t>
+            </a:r>
+          </a:p>
+        </p:txBody>
+      </p:sp>
+      <p:sp>
+        <p:nvSpPr>
+          <p:cNvPr id="6" name="TextBox 5"/>
+          <p:cNvSpPr txBox="1"/>
+          <p:nvPr/>
+        </p:nvSpPr>
+        <p:spPr>
+          <a:xfrm>
+            <a:off x="548640" y="2734056"/>
+            <a:ext cx="11091672" cy="548640"/>
+          </a:xfrm>
+          <a:prstGeom prst="rect">
+            <a:avLst/>
+          </a:prstGeom>
+          <a:noFill/>
+        </p:spPr>
+        <p:txBody>
+          <a:bodyPr wrap="square">
+            <a:spAutoFit/>
+          </a:bodyPr>
+          <a:lstStyle/>
+          <a:p>
+            <a:pPr algn="l"/>
+            <a:r>
+              <a:rPr sz="1800" b="0">
+                <a:solidFill>
+                  <a:srgbClr val="111827"/>
+                </a:solidFill>
+              </a:rPr>
+              <a:t>• Comunicar imediatamente ao superior qualquer condição insegura identificada.</a:t>
+            </a:r>
+          </a:p>
+        </p:txBody>
+      </p:sp>
+      <p:sp>
+        <p:nvSpPr>
+          <p:cNvPr id="7" name="TextBox 6"/>
+          <p:cNvSpPr txBox="1"/>
+          <p:nvPr/>
+        </p:nvSpPr>
+        <p:spPr>
+          <a:xfrm>
+            <a:off x="548640" y="3264408"/>
+            <a:ext cx="11091672" cy="548640"/>
+          </a:xfrm>
+          <a:prstGeom prst="rect">
+            <a:avLst/>
+          </a:prstGeom>
+          <a:noFill/>
+        </p:spPr>
+        <p:txBody>
+          <a:bodyPr wrap="square">
+            <a:spAutoFit/>
+          </a:bodyPr>
+          <a:lstStyle/>
+          <a:p>
+            <a:pPr algn="l"/>
+            <a:r>
+              <a:rPr sz="1800" b="0">
+                <a:solidFill>
+                  <a:srgbClr val="111827"/>
+                </a:solidFill>
+              </a:rPr>
+              <a:t>• Participar de todos os treinamentos e reciclagens promovidos pela empresa.</a:t>
+            </a:r>
+          </a:p>
+        </p:txBody>
+      </p:sp>
+      <p:sp>
+        <p:nvSpPr>
+          <p:cNvPr id="8" name="TextBox 7"/>
+          <p:cNvSpPr txBox="1"/>
+          <p:nvPr/>
+        </p:nvSpPr>
+        <p:spPr>
+          <a:xfrm>
+            <a:off x="548640" y="3794760"/>
+            <a:ext cx="11091672" cy="548640"/>
+          </a:xfrm>
+          <a:prstGeom prst="rect">
+            <a:avLst/>
+          </a:prstGeom>
+          <a:noFill/>
+        </p:spPr>
+        <p:txBody>
+          <a:bodyPr wrap="square">
+            <a:spAutoFit/>
+          </a:bodyPr>
+          <a:lstStyle/>
+          <a:p>
+            <a:pPr algn="l"/>
+            <a:r>
+              <a:rPr sz="1800" b="0">
+                <a:solidFill>
+                  <a:srgbClr val="111827"/>
+                </a:solidFill>
+              </a:rPr>
+              <a:t>• DIREITO DE RECUSA: recusar tarefa de risco grave e iminente SEM PENALIDADES.</a:t>
+            </a:r>
+          </a:p>
+        </p:txBody>
+      </p:sp>
+      <p:sp>
+        <p:nvSpPr>
+          <p:cNvPr id="9" name="TextBox 8"/>
+          <p:cNvSpPr txBox="1"/>
+          <p:nvPr/>
+        </p:nvSpPr>
+        <p:spPr>
+          <a:xfrm>
+            <a:off x="548640" y="4325112"/>
+            <a:ext cx="11091672" cy="548640"/>
+          </a:xfrm>
+          <a:prstGeom prst="rect">
+            <a:avLst/>
+          </a:prstGeom>
+          <a:noFill/>
+        </p:spPr>
+        <p:txBody>
+          <a:bodyPr wrap="square">
+            <a:spAutoFit/>
+          </a:bodyPr>
+          <a:lstStyle/>
+          <a:p>
+            <a:pPr algn="l"/>
+            <a:r>
+              <a:rPr sz="1800" b="0">
+                <a:solidFill>
+                  <a:srgbClr val="111827"/>
+                </a:solidFill>
+              </a:rPr>
+              <a:t>   Comunicar formalmente ao superior e registrar a recusa por escrito.</a:t>
+            </a:r>
+          </a:p>
+        </p:txBody>
+      </p:sp>
+    </p:spTree>
+  </p:cSld>
+  <p:clrMapOvr>
+    <a:masterClrMapping/>
+  </p:clrMapOvr>
+</p:sld>
+</file>
+
+<file path=ppt/slides/slide15.xml><?xml version="1.0" encoding="utf-8"?>
+<p:sld xmlns:a="http://schemas.openxmlformats.org/drawingml/2006/main" xmlns:p="http://schemas.openxmlformats.org/presentationml/2006/main" xmlns:r="http://schemas.openxmlformats.org/officeDocument/2006/relationships">
+  <p:cSld>
+    <p:spTree>
+      <p:nvGrpSpPr>
+        <p:cNvPr id="1" name=""/>
+        <p:cNvGrpSpPr/>
+        <p:nvPr/>
+      </p:nvGrpSpPr>
+      <p:grpSpPr/>
+      <p:sp>
+        <p:nvSpPr>
+          <p:cNvPr id="2" name="TextBox 1"/>
+          <p:cNvSpPr txBox="1"/>
+          <p:nvPr/>
+        </p:nvSpPr>
+        <p:spPr>
+          <a:xfrm>
+            <a:off x="548640" y="228600"/>
+            <a:ext cx="11091672" cy="822960"/>
+          </a:xfrm>
+          <a:prstGeom prst="rect">
+            <a:avLst/>
+          </a:prstGeom>
+          <a:noFill/>
+        </p:spPr>
+        <p:txBody>
+          <a:bodyPr wrap="square">
+            <a:spAutoFit/>
+          </a:bodyPr>
+          <a:lstStyle/>
+          <a:p>
+            <a:pPr algn="l"/>
+            <a:r>
+              <a:rPr sz="2600" b="1">
+                <a:solidFill>
+                  <a:srgbClr val="1A56DB"/>
+                </a:solidFill>
+              </a:rPr>
+              <a:t>Resumo — 10 Pontos Essenciais da NR-10</a:t>
+            </a:r>
+          </a:p>
+        </p:txBody>
+      </p:sp>
+      <p:sp>
+        <p:nvSpPr>
+          <p:cNvPr id="3" name="TextBox 2"/>
+          <p:cNvSpPr txBox="1"/>
+          <p:nvPr/>
+        </p:nvSpPr>
+        <p:spPr>
+          <a:xfrm>
+            <a:off x="548640" y="1143000"/>
+            <a:ext cx="11091672" cy="548640"/>
+          </a:xfrm>
+          <a:prstGeom prst="rect">
+            <a:avLst/>
+          </a:prstGeom>
+          <a:noFill/>
+        </p:spPr>
+        <p:txBody>
+          <a:bodyPr wrap="square">
+            <a:spAutoFit/>
+          </a:bodyPr>
+          <a:lstStyle/>
+          <a:p>
+            <a:pPr algn="l"/>
+            <a:r>
+              <a:rPr sz="1800" b="0">
+                <a:solidFill>
+                  <a:srgbClr val="111827"/>
+                </a:solidFill>
+              </a:rPr>
+              <a:t>1. Aplica-se a TODOS expostos a risco elétrico — não so eletricistas.</a:t>
+            </a:r>
+          </a:p>
+        </p:txBody>
+      </p:sp>
+      <p:sp>
+        <p:nvSpPr>
+          <p:cNvPr id="4" name="TextBox 3"/>
+          <p:cNvSpPr txBox="1"/>
+          <p:nvPr/>
+        </p:nvSpPr>
+        <p:spPr>
+          <a:xfrm>
+            <a:off x="548640" y="1673352"/>
+            <a:ext cx="11091672" cy="548640"/>
+          </a:xfrm>
+          <a:prstGeom prst="rect">
+            <a:avLst/>
+          </a:prstGeom>
+          <a:noFill/>
+        </p:spPr>
+        <p:txBody>
+          <a:bodyPr wrap="square">
+            <a:spAutoFit/>
+          </a:bodyPr>
+          <a:lstStyle/>
+          <a:p>
+            <a:pPr algn="l"/>
+            <a:r>
+              <a:rPr sz="1800" b="0">
+                <a:solidFill>
+                  <a:srgbClr val="111827"/>
+                </a:solidFill>
+              </a:rPr>
+              <a:t>2. Tres perfis: Capacitado (treinado) &gt; Qualificado (certificado) &gt; Habilitado (CREA).</a:t>
+            </a:r>
+          </a:p>
+        </p:txBody>
+      </p:sp>
+      <p:sp>
+        <p:nvSpPr>
+          <p:cNvPr id="5" name="TextBox 4"/>
+          <p:cNvSpPr txBox="1"/>
+          <p:nvPr/>
+        </p:nvSpPr>
+        <p:spPr>
+          <a:xfrm>
+            <a:off x="548640" y="2203704"/>
+            <a:ext cx="11091672" cy="548640"/>
+          </a:xfrm>
+          <a:prstGeom prst="rect">
+            <a:avLst/>
+          </a:prstGeom>
+          <a:noFill/>
+        </p:spPr>
+        <p:txBody>
+          <a:bodyPr wrap="square">
+            <a:spAutoFit/>
+          </a:bodyPr>
+          <a:lstStyle/>
+          <a:p>
+            <a:pPr algn="l"/>
+            <a:r>
+              <a:rPr sz="1800" b="0">
+                <a:solidFill>
+                  <a:srgbClr val="111827"/>
+                </a:solidFill>
+              </a:rPr>
+              <a:t>3. Prontuario obrigatorio — responsabilidade do empregador.</a:t>
+            </a:r>
+          </a:p>
+        </p:txBody>
+      </p:sp>
+      <p:sp>
+        <p:nvSpPr>
+          <p:cNvPr id="6" name="TextBox 5"/>
+          <p:cNvSpPr txBox="1"/>
+          <p:nvPr/>
+        </p:nvSpPr>
+        <p:spPr>
+          <a:xfrm>
+            <a:off x="548640" y="2734056"/>
+            <a:ext cx="11091672" cy="548640"/>
+          </a:xfrm>
+          <a:prstGeom prst="rect">
+            <a:avLst/>
+          </a:prstGeom>
+          <a:noFill/>
+        </p:spPr>
+        <p:txBody>
+          <a:bodyPr wrap="square">
+            <a:spAutoFit/>
+          </a:bodyPr>
+          <a:lstStyle/>
+          <a:p>
+            <a:pPr algn="l"/>
+            <a:r>
+              <a:rPr sz="1800" b="0">
+                <a:solidFill>
+                  <a:srgbClr val="111827"/>
+                </a:solidFill>
+              </a:rPr>
+              <a:t>4. 5 passos LOTO antes de qualquer intervencao elétrica.</a:t>
+            </a:r>
+          </a:p>
+        </p:txBody>
+      </p:sp>
+      <p:sp>
+        <p:nvSpPr>
+          <p:cNvPr id="7" name="TextBox 6"/>
+          <p:cNvSpPr txBox="1"/>
+          <p:nvPr/>
+        </p:nvSpPr>
+        <p:spPr>
+          <a:xfrm>
+            <a:off x="548640" y="3264408"/>
+            <a:ext cx="11091672" cy="548640"/>
+          </a:xfrm>
+          <a:prstGeom prst="rect">
+            <a:avLst/>
+          </a:prstGeom>
+          <a:noFill/>
+        </p:spPr>
+        <p:txBody>
+          <a:bodyPr wrap="square">
+            <a:spAutoFit/>
+          </a:bodyPr>
+          <a:lstStyle/>
+          <a:p>
+            <a:pPr algn="l"/>
+            <a:r>
+              <a:rPr sz="1800" b="0">
+                <a:solidFill>
+                  <a:srgbClr val="111827"/>
+                </a:solidFill>
+              </a:rPr>
+              <a:t>5. NUNCA presuma tensão zero — verifique sempre com instrumento.</a:t>
+            </a:r>
+          </a:p>
+        </p:txBody>
+      </p:sp>
+      <p:sp>
+        <p:nvSpPr>
+          <p:cNvPr id="8" name="TextBox 7"/>
+          <p:cNvSpPr txBox="1"/>
+          <p:nvPr/>
+        </p:nvSpPr>
+        <p:spPr>
+          <a:xfrm>
+            <a:off x="548640" y="3794760"/>
+            <a:ext cx="11091672" cy="548640"/>
+          </a:xfrm>
+          <a:prstGeom prst="rect">
+            <a:avLst/>
+          </a:prstGeom>
+          <a:noFill/>
+        </p:spPr>
+        <p:txBody>
+          <a:bodyPr wrap="square">
+            <a:spAutoFit/>
+          </a:bodyPr>
+          <a:lstStyle/>
+          <a:p>
+            <a:pPr algn="l"/>
+            <a:r>
+              <a:rPr sz="1800" b="0">
+                <a:solidFill>
+                  <a:srgbClr val="111827"/>
+                </a:solidFill>
+              </a:rPr>
+              <a:t>6. Trabalho energizado e EXCECAO — exige AR, PT e habilitado.</a:t>
+            </a:r>
+          </a:p>
+        </p:txBody>
+      </p:sp>
+      <p:sp>
+        <p:nvSpPr>
+          <p:cNvPr id="9" name="TextBox 8"/>
+          <p:cNvSpPr txBox="1"/>
+          <p:nvPr/>
+        </p:nvSpPr>
+        <p:spPr>
+          <a:xfrm>
+            <a:off x="548640" y="4325112"/>
+            <a:ext cx="11091672" cy="548640"/>
+          </a:xfrm>
+          <a:prstGeom prst="rect">
+            <a:avLst/>
+          </a:prstGeom>
+          <a:noFill/>
+        </p:spPr>
+        <p:txBody>
+          <a:bodyPr wrap="square">
+            <a:spAutoFit/>
+          </a:bodyPr>
+          <a:lstStyle/>
+          <a:p>
+            <a:pPr algn="l"/>
+            <a:r>
+              <a:rPr sz="1800" b="0">
+                <a:solidFill>
+                  <a:srgbClr val="111827"/>
+                </a:solidFill>
+              </a:rPr>
+              <a:t>7. EPIs: luvas dieletricas, capacete B, uniforme FR, calcado dieletrico.</a:t>
+            </a:r>
+          </a:p>
+        </p:txBody>
+      </p:sp>
+      <p:sp>
+        <p:nvSpPr>
+          <p:cNvPr id="10" name="TextBox 9"/>
+          <p:cNvSpPr txBox="1"/>
+          <p:nvPr/>
+        </p:nvSpPr>
+        <p:spPr>
+          <a:xfrm>
+            <a:off x="548640" y="4855464"/>
+            <a:ext cx="11091672" cy="548640"/>
+          </a:xfrm>
+          <a:prstGeom prst="rect">
+            <a:avLst/>
+          </a:prstGeom>
+          <a:noFill/>
+        </p:spPr>
+        <p:txBody>
+          <a:bodyPr wrap="square">
+            <a:spAutoFit/>
+          </a:bodyPr>
+          <a:lstStyle/>
+          <a:p>
+            <a:pPr algn="l"/>
+            <a:r>
+              <a:rPr sz="1800" b="0">
+                <a:solidFill>
+                  <a:srgbClr val="111827"/>
+                </a:solidFill>
+              </a:rPr>
+              <a:t>8. Ferramentas: isoladas, dentro da validade, inspecionadas antes do uso.</a:t>
+            </a:r>
+          </a:p>
+        </p:txBody>
+      </p:sp>
+      <p:sp>
+        <p:nvSpPr>
+          <p:cNvPr id="11" name="TextBox 10"/>
+          <p:cNvSpPr txBox="1"/>
+          <p:nvPr/>
+        </p:nvSpPr>
+        <p:spPr>
+          <a:xfrm>
+            <a:off x="548640" y="5385816"/>
+            <a:ext cx="11091672" cy="548640"/>
+          </a:xfrm>
+          <a:prstGeom prst="rect">
+            <a:avLst/>
+          </a:prstGeom>
+          <a:noFill/>
+        </p:spPr>
+        <p:txBody>
+          <a:bodyPr wrap="square">
+            <a:spAutoFit/>
+          </a:bodyPr>
+          <a:lstStyle/>
+          <a:p>
+            <a:pPr algn="l"/>
+            <a:r>
+              <a:rPr sz="1800" b="0">
+                <a:solidFill>
+                  <a:srgbClr val="111827"/>
+                </a:solidFill>
+              </a:rPr>
+              <a:t>9. Reciclagem obrigatoria a cada 2 anos.</a:t>
+            </a:r>
+          </a:p>
+        </p:txBody>
+      </p:sp>
+      <p:sp>
+        <p:nvSpPr>
+          <p:cNvPr id="12" name="TextBox 11"/>
+          <p:cNvSpPr txBox="1"/>
+          <p:nvPr/>
+        </p:nvSpPr>
+        <p:spPr>
+          <a:xfrm>
+            <a:off x="548640" y="5916168"/>
+            <a:ext cx="11091672" cy="548640"/>
+          </a:xfrm>
+          <a:prstGeom prst="rect">
+            <a:avLst/>
+          </a:prstGeom>
+          <a:noFill/>
+        </p:spPr>
+        <p:txBody>
+          <a:bodyPr wrap="square">
+            <a:spAutoFit/>
+          </a:bodyPr>
+          <a:lstStyle/>
+          <a:p>
+            <a:pPr algn="l"/>
+            <a:r>
+              <a:rPr sz="1800" b="0">
+                <a:solidFill>
+                  <a:srgbClr val="111827"/>
+                </a:solidFill>
+              </a:rPr>
+              <a:t>10. Direito de Recusa: recuse risco grave sem medo de penalidades.</a:t>
             </a:r>
           </a:p>
         </p:txBody>
@@ -4552,7 +6504,7 @@
                   <a:srgbClr val="1A56DB"/>
                 </a:solidFill>
               </a:rPr>
-              <a:t>O que é a NR-10 e seu Campo de Aplicação</a:t>
+              <a:t>O que é a NR-10 e para quem se aplica</a:t>
             </a:r>
           </a:p>
         </p:txBody>
@@ -4586,7 +6538,7 @@
                   <a:srgbClr val="111827"/>
                 </a:solidFill>
               </a:rPr>
-              <a:t>• Regulamenta condições mínimas de segurança e saúde para quem trabalha com instalações elétricas.</a:t>
+              <a:t>• Regulamenta segurança e saúde de quem trabalha com instalações elétricas.</a:t>
             </a:r>
           </a:p>
         </p:txBody>
@@ -4620,7 +6572,7 @@
                   <a:srgbClr val="111827"/>
                 </a:solidFill>
               </a:rPr>
-              <a:t>• Aplica-se a todas as fases: projeto, execução, operação, manutenção, reforma e desmontagem.</a:t>
+              <a:t>• Aplica-se em TODAS as fases: projeto, execução, operação, manutenção e desmontagem.</a:t>
             </a:r>
           </a:p>
         </p:txBody>
@@ -4654,7 +6606,7 @@
                   <a:srgbClr val="111827"/>
                 </a:solidFill>
               </a:rPr>
-              <a:t>• Obrigatória para todo trabalhador exposto a riscos elétricos — não apenas eletricistas.</a:t>
+              <a:t>• Obrigatória para QUALQUER trabalhador exposto a risco elétrico — não só eletricistas.</a:t>
             </a:r>
           </a:p>
         </p:txBody>
@@ -4688,7 +6640,7 @@
                   <a:srgbClr val="111827"/>
                 </a:solidFill>
               </a:rPr>
-              <a:t>• Complementada pela NBR 5410 (baixa tensão) e demais normas ABNT aplicáveis.</a:t>
+              <a:t>• Exemplos: pintor que trabalha perto de cabos, pedreiro em obra com rede elétrica.</a:t>
             </a:r>
           </a:p>
         </p:txBody>
@@ -4722,7 +6674,41 @@
                   <a:srgbClr val="111827"/>
                 </a:solidFill>
               </a:rPr>
-              <a:t>• Descumprimento: multas, embargos e interdições pelo Ministério do Trabalho.</a:t>
+              <a:t>• Complementada pela NBR 5410 (baixa tensão) e demais normas ABNT.</a:t>
+            </a:r>
+          </a:p>
+        </p:txBody>
+      </p:sp>
+      <p:sp>
+        <p:nvSpPr>
+          <p:cNvPr id="8" name="TextBox 7"/>
+          <p:cNvSpPr txBox="1"/>
+          <p:nvPr/>
+        </p:nvSpPr>
+        <p:spPr>
+          <a:xfrm>
+            <a:off x="548640" y="3794760"/>
+            <a:ext cx="11091672" cy="548640"/>
+          </a:xfrm>
+          <a:prstGeom prst="rect">
+            <a:avLst/>
+          </a:prstGeom>
+          <a:noFill/>
+        </p:spPr>
+        <p:txBody>
+          <a:bodyPr wrap="square">
+            <a:spAutoFit/>
+          </a:bodyPr>
+          <a:lstStyle/>
+          <a:p>
+            <a:pPr algn="l"/>
+            <a:r>
+              <a:rPr sz="1800" b="0">
+                <a:solidFill>
+                  <a:srgbClr val="111827"/>
+                </a:solidFill>
+              </a:rPr>
+              <a:t>• Descumprimento: multas (NR-28), embargo de obra, interdição do estabelecimento.</a:t>
             </a:r>
           </a:p>
         </p:txBody>
@@ -4774,7 +6760,7 @@
                   <a:srgbClr val="1A56DB"/>
                 </a:solidFill>
               </a:rPr>
-              <a:t>Perfis Profissionais (NR-10, item 10.8)</a:t>
+              <a:t>Perfis Profissionais — NR-10 item 10.8</a:t>
             </a:r>
           </a:p>
         </p:txBody>
@@ -4808,7 +6794,7 @@
                   <a:srgbClr val="111827"/>
                 </a:solidFill>
               </a:rPr>
-              <a:t>• CAPACITADO: recebeu treinamentos de profissional habilitado/qualificado.</a:t>
+              <a:t>CAPACITADO: recebeu treinamentos de profissional habilitado ou qualificado.</a:t>
             </a:r>
           </a:p>
         </p:txBody>
@@ -4842,7 +6828,7 @@
                   <a:srgbClr val="111827"/>
                 </a:solidFill>
               </a:rPr>
-              <a:t>           Autorizado para tarefas específicas. Não exige registro em conselho.</a:t>
+              <a:t>   Autorizado para tarefas específicas e limitadas. SEM registro em conselho.</a:t>
             </a:r>
           </a:p>
         </p:txBody>
@@ -4876,7 +6862,7 @@
                   <a:srgbClr val="111827"/>
                 </a:solidFill>
               </a:rPr>
-              <a:t>• QUALIFICADO: concluiu curso técnico na área elétrica com certificado profissionalizante.</a:t>
+              <a:t>QUALIFICADO: concluiu curso técnico específico na área elétrica.</a:t>
             </a:r>
           </a:p>
         </p:txBody>
@@ -4910,7 +6896,7 @@
                   <a:srgbClr val="111827"/>
                 </a:solidFill>
               </a:rPr>
-              <a:t>           Não exige registro em conselho de classe.</a:t>
+              <a:t>   Possui certificado profissionalizante. SEM necessidade de registro em conselho.</a:t>
             </a:r>
           </a:p>
         </p:txBody>
@@ -4944,7 +6930,7 @@
                   <a:srgbClr val="111827"/>
                 </a:solidFill>
               </a:rPr>
-              <a:t>• HABILITADO: além do curso técnico ou graduação, possui registro no CREA ou CRT.</a:t>
+              <a:t>HABILITADO: além do curso, possui registro no conselho de classe (CREA / CRT).</a:t>
             </a:r>
           </a:p>
         </p:txBody>
@@ -4978,7 +6964,7 @@
                   <a:srgbClr val="111827"/>
                 </a:solidFill>
               </a:rPr>
-              <a:t>           Máxima autonomia técnica — pode assinar laudos e projetos.</a:t>
+              <a:t>   Máxima autonomia — pode assinar laudos, projetos e Análise de Risco.</a:t>
             </a:r>
           </a:p>
         </p:txBody>
@@ -5012,7 +6998,7 @@
                   <a:srgbClr val="111827"/>
                 </a:solidFill>
               </a:rPr>
-              <a:t>• PRONTUÁRIO: documento que reúne projetos, laudos e registros da instalação. Obrigação do empregador.</a:t>
+              <a:t>PRONTUÁRIO: documento que registra toda a conformidade das instalações. Obrigação do empregador.</a:t>
             </a:r>
           </a:p>
         </p:txBody>
@@ -5064,7 +7050,7 @@
                   <a:srgbClr val="1A56DB"/>
                 </a:solidFill>
               </a:rPr>
-              <a:t>Sequência de Controle — 5 Passos Obrigatórios</a:t>
+              <a:t>Prontuário de Instalações Elétricas</a:t>
             </a:r>
           </a:p>
         </p:txBody>
@@ -5098,7 +7084,7 @@
                   <a:srgbClr val="111827"/>
                 </a:solidFill>
               </a:rPr>
-              <a:t>1. DESENERGIZAÇÃO — desligar todas as fontes (chaves, disjuntores, religadores).</a:t>
+              <a:t>• Documento obrigatório que comprova a conformidade da instalação com a NR-10.</a:t>
             </a:r>
           </a:p>
         </p:txBody>
@@ -5132,7 +7118,7 @@
                   <a:srgbClr val="111827"/>
                 </a:solidFill>
               </a:rPr>
-              <a:t>2. SECCIONAMENTO — isolar fisicamente o trecho onde será feito o trabalho.</a:t>
+              <a:t>• Deve conter: projetos, memoriais descritivos, diagramas unifilares e funcionais.</a:t>
             </a:r>
           </a:p>
         </p:txBody>
@@ -5166,7 +7152,7 @@
                   <a:srgbClr val="111827"/>
                 </a:solidFill>
               </a:rPr>
-              <a:t>3. VERIFICAR AUSÊNCIA DE TENSÃO — usar instrumento adequado. NUNCA presuma.</a:t>
+              <a:t>• Inclui: laudos, relatórios de inspeção, ART do responsável técnico.</a:t>
             </a:r>
           </a:p>
         </p:txBody>
@@ -5200,7 +7186,7 @@
                   <a:srgbClr val="111827"/>
                 </a:solidFill>
               </a:rPr>
-              <a:t>4. ATERRAMENTO PROVISÓRIO — aterrar e curto-circuitar os condutores.</a:t>
+              <a:t>• Deve ser mantido ATUALIZADO e disponível para fiscalização a qualquer momento.</a:t>
             </a:r>
           </a:p>
         </p:txBody>
@@ -5234,7 +7220,41 @@
                   <a:srgbClr val="111827"/>
                 </a:solidFill>
               </a:rPr>
-              <a:t>5. SINALIZAÇÃO / BLOQUEIO (LOTO) — cadeado + placa 'Não ligue — homem trabalhando'.</a:t>
+              <a:t>• Responsabilidade do EMPREGADOR — não do técnico ou engenheiro contratado.</a:t>
+            </a:r>
+          </a:p>
+        </p:txBody>
+      </p:sp>
+      <p:sp>
+        <p:nvSpPr>
+          <p:cNvPr id="8" name="TextBox 7"/>
+          <p:cNvSpPr txBox="1"/>
+          <p:nvPr/>
+        </p:nvSpPr>
+        <p:spPr>
+          <a:xfrm>
+            <a:off x="548640" y="3794760"/>
+            <a:ext cx="11091672" cy="548640"/>
+          </a:xfrm>
+          <a:prstGeom prst="rect">
+            <a:avLst/>
+          </a:prstGeom>
+          <a:noFill/>
+        </p:spPr>
+        <p:txBody>
+          <a:bodyPr wrap="square">
+            <a:spAutoFit/>
+          </a:bodyPr>
+          <a:lstStyle/>
+          <a:p>
+            <a:pPr algn="l"/>
+            <a:r>
+              <a:rPr sz="1800" b="0">
+                <a:solidFill>
+                  <a:srgbClr val="111827"/>
+                </a:solidFill>
+              </a:rPr>
+              <a:t>• Ausência ou desatualização do Prontuário sujeita o empregador a autuação imediata.</a:t>
             </a:r>
           </a:p>
         </p:txBody>
@@ -5286,7 +7306,7 @@
                   <a:srgbClr val="1A56DB"/>
                 </a:solidFill>
               </a:rPr>
-              <a:t>Zonas de Trabalho em Instalações Elétricas</a:t>
+              <a:t>Sequência de Controle — 5 Passos (LOTO)</a:t>
             </a:r>
           </a:p>
         </p:txBody>
@@ -5320,7 +7340,7 @@
                   <a:srgbClr val="111827"/>
                 </a:solidFill>
               </a:rPr>
-              <a:t>🔴 ZONA DE RISCO (ZR): próxima de partes energizadas. Só habilitados com EPIs.</a:t>
+              <a:t>Obrigatória ANTES de qualquer intervenção em instalação elétrica:</a:t>
             </a:r>
           </a:p>
         </p:txBody>
@@ -5354,7 +7374,7 @@
                   <a:srgbClr val="111827"/>
                 </a:solidFill>
               </a:rPr>
-              <a:t>🟡 ZONA CONTROLADA (ZC): ao redor da ZR. Acesso restrito e controlado.</a:t>
+              <a:t>1. DESENERGIZAÇÃO: desligar todas as fontes (disjuntores, chaves, religadores).</a:t>
             </a:r>
           </a:p>
         </p:txBody>
@@ -5388,7 +7408,7 @@
                   <a:srgbClr val="111827"/>
                 </a:solidFill>
               </a:rPr>
-              <a:t>🔵 ZONA DE VIZINHANÇA (ZV): além da ZC. Pessoas informadas dos riscos.</a:t>
+              <a:t>2. SECCIONAMENTO: isolar fisicamente o trecho do circuito a ser trabalhado.</a:t>
             </a:r>
           </a:p>
         </p:txBody>
@@ -5422,7 +7442,7 @@
                   <a:srgbClr val="111827"/>
                 </a:solidFill>
               </a:rPr>
-              <a:t>🟢 TRABALHO DESENERGIZADO: condição preferencial — seguir os 5 passos.</a:t>
+              <a:t>3. VERIFICAR AUSÊNCIA DE TENSÃO: instrumento calibrado — NUNCA presuma.</a:t>
             </a:r>
           </a:p>
         </p:txBody>
@@ -5456,7 +7476,75 @@
                   <a:srgbClr val="111827"/>
                 </a:solidFill>
               </a:rPr>
-              <a:t>⚠️  As distâncias de cada zona variam conforme o nível de tensão (BT, MT ou AT).</a:t>
+              <a:t>4. ATERRAMENTO PROVISÓRIO: aterrar e curto-circuitar condutores do trecho.</a:t>
+            </a:r>
+          </a:p>
+        </p:txBody>
+      </p:sp>
+      <p:sp>
+        <p:nvSpPr>
+          <p:cNvPr id="8" name="TextBox 7"/>
+          <p:cNvSpPr txBox="1"/>
+          <p:nvPr/>
+        </p:nvSpPr>
+        <p:spPr>
+          <a:xfrm>
+            <a:off x="548640" y="3794760"/>
+            <a:ext cx="11091672" cy="548640"/>
+          </a:xfrm>
+          <a:prstGeom prst="rect">
+            <a:avLst/>
+          </a:prstGeom>
+          <a:noFill/>
+        </p:spPr>
+        <p:txBody>
+          <a:bodyPr wrap="square">
+            <a:spAutoFit/>
+          </a:bodyPr>
+          <a:lstStyle/>
+          <a:p>
+            <a:pPr algn="l"/>
+            <a:r>
+              <a:rPr sz="1800" b="0">
+                <a:solidFill>
+                  <a:srgbClr val="111827"/>
+                </a:solidFill>
+              </a:rPr>
+              <a:t>5. SINALIZAÇÃO / LOTO: cadeado individual + placa 'Nao ligue — homem trabalhando'.</a:t>
+            </a:r>
+          </a:p>
+        </p:txBody>
+      </p:sp>
+      <p:sp>
+        <p:nvSpPr>
+          <p:cNvPr id="9" name="TextBox 8"/>
+          <p:cNvSpPr txBox="1"/>
+          <p:nvPr/>
+        </p:nvSpPr>
+        <p:spPr>
+          <a:xfrm>
+            <a:off x="548640" y="4325112"/>
+            <a:ext cx="11091672" cy="548640"/>
+          </a:xfrm>
+          <a:prstGeom prst="rect">
+            <a:avLst/>
+          </a:prstGeom>
+          <a:noFill/>
+        </p:spPr>
+        <p:txBody>
+          <a:bodyPr wrap="square">
+            <a:spAutoFit/>
+          </a:bodyPr>
+          <a:lstStyle/>
+          <a:p>
+            <a:pPr algn="l"/>
+            <a:r>
+              <a:rPr sz="1800" b="0">
+                <a:solidFill>
+                  <a:srgbClr val="111827"/>
+                </a:solidFill>
+              </a:rPr>
+              <a:t>Somente apos todos os 5 passos o trabalho pode ser iniciado com seguranca.</a:t>
             </a:r>
           </a:p>
         </p:txBody>
@@ -5508,7 +7596,7 @@
                   <a:srgbClr val="1A56DB"/>
                 </a:solidFill>
               </a:rPr>
-              <a:t>Trabalho em Instalações Energizadas</a:t>
+              <a:t>LOTO — Lockout / Tagout em Detalhes</a:t>
             </a:r>
           </a:p>
         </p:txBody>
@@ -5542,7 +7630,7 @@
                   <a:srgbClr val="111827"/>
                 </a:solidFill>
               </a:rPr>
-              <a:t>• É EXCEÇÃO, não regra — só permitido quando a desenergização for inviável.</a:t>
+              <a:t>LOCKOUT (bloqueio físico):</a:t>
             </a:r>
           </a:p>
         </p:txBody>
@@ -5576,7 +7664,7 @@
                   <a:srgbClr val="111827"/>
                 </a:solidFill>
               </a:rPr>
-              <a:t>• Exige Análise de Risco (AR) e emissão de Permissão de Trabalho (PT).</a:t>
+              <a:t>   Cadeado individual colocado na chave, disjuntor ou válvula de energia.</a:t>
             </a:r>
           </a:p>
         </p:txBody>
@@ -5610,7 +7698,7 @@
                   <a:srgbClr val="111827"/>
                 </a:solidFill>
               </a:rPr>
-              <a:t>• Realizado por profissional HABILITADO com supervisão e ao menos mais um capacitado.</a:t>
+              <a:t>   Cada trabalhador usa SEU cadeado — não pode ser removido por outra pessoa.</a:t>
             </a:r>
           </a:p>
         </p:txBody>
@@ -5644,7 +7732,7 @@
                   <a:srgbClr val="111827"/>
                 </a:solidFill>
               </a:rPr>
-              <a:t>• EPIs obrigatórios: luvas dielétricas, capacete classe B, óculos, uniforme anti-chama.</a:t>
+              <a:t>TAGOUT (etiqueta de sinalização):</a:t>
             </a:r>
           </a:p>
         </p:txBody>
@@ -5678,7 +7766,75 @@
                   <a:srgbClr val="111827"/>
                 </a:solidFill>
               </a:rPr>
-              <a:t>• Ferramentas devem ser isoladas/dielétricas, inspecionadas e dentro da validade.</a:t>
+              <a:t>   Placa de aviso: 'Nao ligue — Homem trabalhando — Nome do responsavel'.</a:t>
+            </a:r>
+          </a:p>
+        </p:txBody>
+      </p:sp>
+      <p:sp>
+        <p:nvSpPr>
+          <p:cNvPr id="8" name="TextBox 7"/>
+          <p:cNvSpPr txBox="1"/>
+          <p:nvPr/>
+        </p:nvSpPr>
+        <p:spPr>
+          <a:xfrm>
+            <a:off x="548640" y="3794760"/>
+            <a:ext cx="11091672" cy="548640"/>
+          </a:xfrm>
+          <a:prstGeom prst="rect">
+            <a:avLst/>
+          </a:prstGeom>
+          <a:noFill/>
+        </p:spPr>
+        <p:txBody>
+          <a:bodyPr wrap="square">
+            <a:spAutoFit/>
+          </a:bodyPr>
+          <a:lstStyle/>
+          <a:p>
+            <a:pPr algn="l"/>
+            <a:r>
+              <a:rPr sz="1800" b="0">
+                <a:solidFill>
+                  <a:srgbClr val="111827"/>
+                </a:solidFill>
+              </a:rPr>
+              <a:t>Se mais de 1 trabalhador: cada um coloca SEU cadeado (vários cadeados, 1 por pessoa).</a:t>
+            </a:r>
+          </a:p>
+        </p:txBody>
+      </p:sp>
+      <p:sp>
+        <p:nvSpPr>
+          <p:cNvPr id="9" name="TextBox 8"/>
+          <p:cNvSpPr txBox="1"/>
+          <p:nvPr/>
+        </p:nvSpPr>
+        <p:spPr>
+          <a:xfrm>
+            <a:off x="548640" y="4325112"/>
+            <a:ext cx="11091672" cy="548640"/>
+          </a:xfrm>
+          <a:prstGeom prst="rect">
+            <a:avLst/>
+          </a:prstGeom>
+          <a:noFill/>
+        </p:spPr>
+        <p:txBody>
+          <a:bodyPr wrap="square">
+            <a:spAutoFit/>
+          </a:bodyPr>
+          <a:lstStyle/>
+          <a:p>
+            <a:pPr algn="l"/>
+            <a:r>
+              <a:rPr sz="1800" b="0">
+                <a:solidFill>
+                  <a:srgbClr val="111827"/>
+                </a:solidFill>
+              </a:rPr>
+              <a:t>Somente o trabalhador que colocou o cadeado pode removê-lo ao finalizar o servico.</a:t>
             </a:r>
           </a:p>
         </p:txBody>
@@ -5730,7 +7886,7 @@
                   <a:srgbClr val="1A56DB"/>
                 </a:solidFill>
               </a:rPr>
-              <a:t>EPIs Obrigatórios para Trabalho Elétrico (NR-06 + NR-10)</a:t>
+              <a:t>Trabalho Desenergizado × Trabalho Energizado</a:t>
             </a:r>
           </a:p>
         </p:txBody>
@@ -5764,7 +7920,7 @@
                   <a:srgbClr val="111827"/>
                 </a:solidFill>
               </a:rPr>
-              <a:t>🧤 Luvas dielétricas — classificadas por classe de tensão (0 a 4).</a:t>
+              <a:t>DESENERGIZADO (preferencial — deve ser sempre a primeira opção):</a:t>
             </a:r>
           </a:p>
         </p:txBody>
@@ -5798,7 +7954,7 @@
                   <a:srgbClr val="111827"/>
                 </a:solidFill>
               </a:rPr>
-              <a:t>   Inspecionar antes de cada uso: soprar e verificar furos.</a:t>
+              <a:t>   Segue os 5 passos. Menor risco. Exige capacitado ou superior.</a:t>
             </a:r>
           </a:p>
         </p:txBody>
@@ -5832,7 +7988,7 @@
                   <a:srgbClr val="111827"/>
                 </a:solidFill>
               </a:rPr>
-              <a:t>⛑️  Capacete classe B (isolante até 20.000 V) com jugular.</a:t>
+              <a:t>ENERGIZADO (exceção — somente quando inviável a desenergização):</a:t>
             </a:r>
           </a:p>
         </p:txBody>
@@ -5866,7 +8022,7 @@
                   <a:srgbClr val="111827"/>
                 </a:solidFill>
               </a:rPr>
-              <a:t>   Óculos de proteção contra arco elétrico.</a:t>
+              <a:t>   Exige justificativa técnica formal (por escrito).</a:t>
             </a:r>
           </a:p>
         </p:txBody>
@@ -5900,7 +8056,7 @@
                   <a:srgbClr val="111827"/>
                 </a:solidFill>
               </a:rPr>
-              <a:t>👟 Calçado com solado dielétrico — sem partes metálicas expostas.</a:t>
+              <a:t>   Análise de Risco (AR) elaborada por habilitado/qualificado.</a:t>
             </a:r>
           </a:p>
         </p:txBody>
@@ -5934,7 +8090,75 @@
                   <a:srgbClr val="111827"/>
                 </a:solidFill>
               </a:rPr>
-              <a:t>👕 Uniforme anti-chama (FR) — proibido tecido sintético (derrete e gruda).</a:t>
+              <a:t>   Permissão de Trabalho (PT) emitida antes do início do servico.</a:t>
+            </a:r>
+          </a:p>
+        </p:txBody>
+      </p:sp>
+      <p:sp>
+        <p:nvSpPr>
+          <p:cNvPr id="9" name="TextBox 8"/>
+          <p:cNvSpPr txBox="1"/>
+          <p:nvPr/>
+        </p:nvSpPr>
+        <p:spPr>
+          <a:xfrm>
+            <a:off x="548640" y="4325112"/>
+            <a:ext cx="11091672" cy="548640"/>
+          </a:xfrm>
+          <a:prstGeom prst="rect">
+            <a:avLst/>
+          </a:prstGeom>
+          <a:noFill/>
+        </p:spPr>
+        <p:txBody>
+          <a:bodyPr wrap="square">
+            <a:spAutoFit/>
+          </a:bodyPr>
+          <a:lstStyle/>
+          <a:p>
+            <a:pPr algn="l"/>
+            <a:r>
+              <a:rPr sz="1800" b="0">
+                <a:solidFill>
+                  <a:srgbClr val="111827"/>
+                </a:solidFill>
+              </a:rPr>
+              <a:t>   Executado por HABILITADO + ao menos 1 capacitado presente.</a:t>
+            </a:r>
+          </a:p>
+        </p:txBody>
+      </p:sp>
+      <p:sp>
+        <p:nvSpPr>
+          <p:cNvPr id="10" name="TextBox 9"/>
+          <p:cNvSpPr txBox="1"/>
+          <p:nvPr/>
+        </p:nvSpPr>
+        <p:spPr>
+          <a:xfrm>
+            <a:off x="548640" y="4855464"/>
+            <a:ext cx="11091672" cy="548640"/>
+          </a:xfrm>
+          <a:prstGeom prst="rect">
+            <a:avLst/>
+          </a:prstGeom>
+          <a:noFill/>
+        </p:spPr>
+        <p:txBody>
+          <a:bodyPr wrap="square">
+            <a:spAutoFit/>
+          </a:bodyPr>
+          <a:lstStyle/>
+          <a:p>
+            <a:pPr algn="l"/>
+            <a:r>
+              <a:rPr sz="1800" b="0">
+                <a:solidFill>
+                  <a:srgbClr val="111827"/>
+                </a:solidFill>
+              </a:rPr>
+              <a:t>   EPIs dielétricos obrigatórios (luvas, capacete B, uniforme anti-chama).</a:t>
             </a:r>
           </a:p>
         </p:txBody>
@@ -5986,7 +8210,7 @@
                   <a:srgbClr val="1A56DB"/>
                 </a:solidFill>
               </a:rPr>
-              <a:t>NBR 5410 e sua Relação com a NR-10</a:t>
+              <a:t>Análise de Risco (AR) e Permissão de Trabalho (PT)</a:t>
             </a:r>
           </a:p>
         </p:txBody>
@@ -6020,7 +8244,7 @@
                   <a:srgbClr val="111827"/>
                 </a:solidFill>
               </a:rPr>
-              <a:t>NR-10 (trabalhista) — segurança de quem trabalha com eletricidade (pessoas).</a:t>
+              <a:t>AR — Análise de Risco:</a:t>
             </a:r>
           </a:p>
         </p:txBody>
@@ -6054,7 +8278,7 @@
                   <a:srgbClr val="111827"/>
                 </a:solidFill>
               </a:rPr>
-              <a:t>NBR 5410 (ABNT)    — projeto e execução de instalações de baixa tensão.</a:t>
+              <a:t>   Elaborada por habilitado ou qualificado com conhecimento da instalação.</a:t>
             </a:r>
           </a:p>
         </p:txBody>
@@ -6088,7 +8312,7 @@
                   <a:srgbClr val="111827"/>
                 </a:solidFill>
               </a:rPr>
-              <a:t>NBR 14039 (ABNT)   — instalações de média tensão.</a:t>
+              <a:t>   Identifica os perigos, avalia a gravidade e define os controles necessários.</a:t>
             </a:r>
           </a:p>
         </p:txBody>
@@ -6122,7 +8346,7 @@
                   <a:srgbClr val="111827"/>
                 </a:solidFill>
               </a:rPr>
-              <a:t>NBR 5419 (ABNT)    — SPDA, proteção contra descargas atmosféricas.</a:t>
+              <a:t>   Específica para cada serviço — não é genérica.</a:t>
             </a:r>
           </a:p>
         </p:txBody>
@@ -6156,7 +8380,7 @@
                   <a:srgbClr val="111827"/>
                 </a:solidFill>
               </a:rPr>
-              <a:t>NBR IEC 60900      — ferramentas isoladas para trabalho energizado.</a:t>
+              <a:t>PT — Permissão de Trabalho:</a:t>
             </a:r>
           </a:p>
         </p:txBody>
@@ -6190,7 +8414,75 @@
                   <a:srgbClr val="111827"/>
                 </a:solidFill>
               </a:rPr>
-              <a:t>Conclusão: NR-10 protege o trabalhador; NBR 5410 protege a instalação.</a:t>
+              <a:t>   Documento formal que autoriza o início do trabalho em instalação energizada.</a:t>
+            </a:r>
+          </a:p>
+        </p:txBody>
+      </p:sp>
+      <p:sp>
+        <p:nvSpPr>
+          <p:cNvPr id="9" name="TextBox 8"/>
+          <p:cNvSpPr txBox="1"/>
+          <p:nvPr/>
+        </p:nvSpPr>
+        <p:spPr>
+          <a:xfrm>
+            <a:off x="548640" y="4325112"/>
+            <a:ext cx="11091672" cy="548640"/>
+          </a:xfrm>
+          <a:prstGeom prst="rect">
+            <a:avLst/>
+          </a:prstGeom>
+          <a:noFill/>
+        </p:spPr>
+        <p:txBody>
+          <a:bodyPr wrap="square">
+            <a:spAutoFit/>
+          </a:bodyPr>
+          <a:lstStyle/>
+          <a:p>
+            <a:pPr algn="l"/>
+            <a:r>
+              <a:rPr sz="1800" b="0">
+                <a:solidFill>
+                  <a:srgbClr val="111827"/>
+                </a:solidFill>
+              </a:rPr>
+              <a:t>   Deve conter: local, data, serviço, riscos, EPIs, responsáveis e assinaturas.</a:t>
+            </a:r>
+          </a:p>
+        </p:txBody>
+      </p:sp>
+      <p:sp>
+        <p:nvSpPr>
+          <p:cNvPr id="10" name="TextBox 9"/>
+          <p:cNvSpPr txBox="1"/>
+          <p:nvPr/>
+        </p:nvSpPr>
+        <p:spPr>
+          <a:xfrm>
+            <a:off x="548640" y="4855464"/>
+            <a:ext cx="11091672" cy="548640"/>
+          </a:xfrm>
+          <a:prstGeom prst="rect">
+            <a:avLst/>
+          </a:prstGeom>
+          <a:noFill/>
+        </p:spPr>
+        <p:txBody>
+          <a:bodyPr wrap="square">
+            <a:spAutoFit/>
+          </a:bodyPr>
+          <a:lstStyle/>
+          <a:p>
+            <a:pPr algn="l"/>
+            <a:r>
+              <a:rPr sz="1800" b="0">
+                <a:solidFill>
+                  <a:srgbClr val="111827"/>
+                </a:solidFill>
+              </a:rPr>
+              <a:t>   Válida apenas para aquele serviço específico — encerrada ao final.</a:t>
             </a:r>
           </a:p>
         </p:txBody>
@@ -6242,7 +8534,7 @@
                   <a:srgbClr val="1A56DB"/>
                 </a:solidFill>
               </a:rPr>
-              <a:t>Responsabilidades e Penalidades</a:t>
+              <a:t>Zonas de Trabalho em Instalações Elétricas</a:t>
             </a:r>
           </a:p>
         </p:txBody>
@@ -6276,7 +8568,7 @@
                   <a:srgbClr val="111827"/>
                 </a:solidFill>
               </a:rPr>
-              <a:t>EMPREGADOR deve: garantir instalações conformes, manter Prontuário atualizado,</a:t>
+              <a:t>Zonas definidas em relação às partes ENERGIZADAS da instalacao:</a:t>
             </a:r>
           </a:p>
         </p:txBody>
@@ -6310,7 +8602,7 @@
                   <a:srgbClr val="111827"/>
                 </a:solidFill>
               </a:rPr>
-              <a:t>  fornecer EPIs gratuitamente, promover treinamentos a cada 2 anos,</a:t>
+              <a:t>ZONA DE RISCO (ZR): proximidade tal que o contato acidental e muito provavel.</a:t>
             </a:r>
           </a:p>
         </p:txBody>
@@ -6344,7 +8636,7 @@
                   <a:srgbClr val="111827"/>
                 </a:solidFill>
               </a:rPr>
-              <a:t>  emitir AR e PT, garantir profissional habilitado na supervisão.</a:t>
+              <a:t>   Acesso: somente habilitados com EPIs dielétricos adequados.</a:t>
             </a:r>
           </a:p>
         </p:txBody>
@@ -6378,7 +8670,7 @@
                   <a:srgbClr val="111827"/>
                 </a:solidFill>
               </a:rPr>
-              <a:t>TRABALHADOR deve: seguir os 5 passos, usar EPIs corretamente,</a:t>
+              <a:t>ZONA CONTROLADA (ZC): ao redor da ZR. Acesso restrito e supervisionado.</a:t>
             </a:r>
           </a:p>
         </p:txBody>
@@ -6412,7 +8704,7 @@
                   <a:srgbClr val="111827"/>
                 </a:solidFill>
               </a:rPr>
-              <a:t>  NUNCA presumir desenergização, comunicar condições inseguras,</a:t>
+              <a:t>   Acesso: capacitados, qualificados ou habilitados com autorização.</a:t>
             </a:r>
           </a:p>
         </p:txBody>
@@ -6446,7 +8738,7 @@
                   <a:srgbClr val="111827"/>
                 </a:solidFill>
               </a:rPr>
-              <a:t>  exercer o Direito de Recusa em caso de risco grave e iminente.</a:t>
+              <a:t>ZONA DE VIZINHANÇA (ZV): além da ZC. Acesso permitido com informação de riscos.</a:t>
             </a:r>
           </a:p>
         </p:txBody>
@@ -6480,7 +8772,7 @@
                   <a:srgbClr val="111827"/>
                 </a:solidFill>
               </a:rPr>
-              <a:t>⚠️  Penalidades: multas (NR-28), embargo, interdição, ações trabalhistas.</a:t>
+              <a:t>As distâncias de cada zona variam conforme o nível de tensão (BT, MT ou AT).</a:t>
             </a:r>
           </a:p>
         </p:txBody>

</xml_diff>